<commit_message>
making some changes to the dashboard
</commit_message>
<xml_diff>
--- a/deck/ET_AI_Hackathon_2026_Cyber_Resilience_Deck.pptx
+++ b/deck/ET_AI_Hackathon_2026_Cyber_Resilience_Deck.pptx
@@ -4,6 +4,9 @@
   <p:sldMasterIdLst>
     <p:sldMasterId id="2147483648" r:id="rId1"/>
   </p:sldMasterIdLst>
+  <p:notesMasterIdLst>
+    <p:notesMasterId r:id="rId14"/>
+  </p:notesMasterIdLst>
   <p:sldIdLst>
     <p:sldId id="256" r:id="rId2"/>
     <p:sldId id="257" r:id="rId3"/>
@@ -18,9 +21,6 @@
     <p:sldId id="266" r:id="rId12"/>
     <p:sldId id="267" r:id="rId13"/>
   </p:sldIdLst>
-  <p:notesMasterIdLst>
-    <p:notesMasterId r:id="rId14"/>
-  </p:notesMasterIdLst>
   <p:sldSz cx="12192000" cy="6858000"/>
   <p:notesSz cx="6858000" cy="12192000"/>
   <p:defaultTextStyle>
@@ -115,13 +115,20 @@
       </a:defRPr>
     </a:lvl9pPr>
   </p:defaultTextStyle>
+  <p:extLst>
+    <p:ext uri="{EFAFB233-063F-42B5-8137-9DF3F51BA10A}">
+      <p15:sldGuideLst xmlns:p15="http://schemas.microsoft.com/office/powerpoint/2012/main"/>
+    </p:ext>
+  </p:extLst>
 </p:presentation>
 </file>
 
 <file path=ppt/charts/chart1.xml><?xml version="1.0" encoding="utf-8"?>
-<c:chartSpace xmlns:c="http://schemas.openxmlformats.org/drawingml/2006/chart" xmlns:a="http://schemas.openxmlformats.org/drawingml/2006/main" xmlns:r="http://schemas.openxmlformats.org/officeDocument/2006/relationships">
+<c:chartSpace xmlns:c="http://schemas.openxmlformats.org/drawingml/2006/chart" xmlns:a="http://schemas.openxmlformats.org/drawingml/2006/main" xmlns:r="http://schemas.openxmlformats.org/officeDocument/2006/relationships" xmlns:c16r2="http://schemas.microsoft.com/office/drawing/2015/06/chart">
   <c:date1904 val="0"/>
+  <c:lang val="en-GB"/>
   <c:roundedCorners val="1"/>
+  <c:style val="2"/>
   <c:chart>
     <c:title>
       <c:tx>
@@ -138,7 +145,7 @@
               </a:defRPr>
             </a:pPr>
             <a:r>
-              <a:rPr sz="1300" b="0" i="0" u="none" strike="noStrike">
+              <a:rPr lang="en-IN" sz="1300" b="0" i="0" u="none" strike="noStrike">
                 <a:solidFill>
                   <a:srgbClr val="141B2E"/>
                 </a:solidFill>
@@ -149,7 +156,6 @@
           </a:p>
         </c:rich>
       </c:tx>
-      <c:layout/>
       <c:overlay val="0"/>
     </c:title>
     <c:autoTitleDeleted val="0"/>
@@ -182,18 +188,26 @@
           <c:invertIfNegative val="0"/>
           <c:dLbls>
             <c:numFmt formatCode="#,##0" sourceLinked="0"/>
+            <c:spPr>
+              <a:noFill/>
+              <a:ln>
+                <a:noFill/>
+              </a:ln>
+              <a:effectLst/>
+            </c:spPr>
             <c:txPr>
               <a:bodyPr/>
               <a:lstStyle/>
               <a:p>
                 <a:pPr>
-                  <a:defRPr b="0" i="0" strike="noStrike" sz="900" u="none">
+                  <a:defRPr sz="900" b="0" i="0" u="none" strike="noStrike">
                     <a:solidFill>
                       <a:srgbClr val="141B2E"/>
                     </a:solidFill>
                     <a:latin typeface="Arial"/>
                   </a:defRPr>
                 </a:pPr>
+                <a:endParaRPr lang="en-US"/>
               </a:p>
             </c:txPr>
             <c:showLegendKey val="0"/>
@@ -203,31 +217,34 @@
             <c:showPercent val="0"/>
             <c:showBubbleSize val="0"/>
             <c:showLeaderLines val="0"/>
+            <c:extLst>
+              <c:ext xmlns:c15="http://schemas.microsoft.com/office/drawing/2012/chart" uri="{CE6537A1-D6FC-4f65-9D91-7224C49458BB}">
+                <c15:showLeaderLines val="0"/>
+              </c:ext>
+            </c:extLst>
           </c:dLbls>
           <c:cat>
-            <c:multiLvlStrRef>
+            <c:strRef>
               <c:f>Sheet1!$A$2:$A$6</c:f>
-              <c:multiLvlStrCache>
+              <c:strCache>
                 <c:ptCount val="5"/>
-                <c:lvl>
-                  <c:pt idx="0">
-                    <c:v>Port scan</c:v>
-                  </c:pt>
-                  <c:pt idx="1">
-                    <c:v>Brute force</c:v>
-                  </c:pt>
-                  <c:pt idx="2">
-                    <c:v>DoS</c:v>
-                  </c:pt>
-                  <c:pt idx="3">
-                    <c:v>Exfiltration</c:v>
-                  </c:pt>
-                  <c:pt idx="4">
-                    <c:v>Lateral movement</c:v>
-                  </c:pt>
-                </c:lvl>
-              </c:multiLvlStrCache>
-            </c:multiLvlStrRef>
+                <c:pt idx="0">
+                  <c:v>Port scan</c:v>
+                </c:pt>
+                <c:pt idx="1">
+                  <c:v>Brute force</c:v>
+                </c:pt>
+                <c:pt idx="2">
+                  <c:v>DoS</c:v>
+                </c:pt>
+                <c:pt idx="3">
+                  <c:v>Exfiltration</c:v>
+                </c:pt>
+                <c:pt idx="4">
+                  <c:v>Lateral movement</c:v>
+                </c:pt>
+              </c:strCache>
+            </c:strRef>
           </c:cat>
           <c:val>
             <c:numRef>
@@ -253,6 +270,11 @@
               </c:numCache>
             </c:numRef>
           </c:val>
+          <c:extLst>
+            <c:ext xmlns:c16="http://schemas.microsoft.com/office/drawing/2014/chart" uri="{C3380CC4-5D6E-409C-BE32-E72D297353CC}">
+              <c16:uniqueId val="{00000000-4EEE-3E46-9274-97A9B688C4C7}"/>
+            </c:ext>
+          </c:extLst>
         </c:ser>
         <c:ser>
           <c:idx val="1"/>
@@ -277,18 +299,26 @@
           <c:invertIfNegative val="0"/>
           <c:dLbls>
             <c:numFmt formatCode="#,##0" sourceLinked="0"/>
+            <c:spPr>
+              <a:noFill/>
+              <a:ln>
+                <a:noFill/>
+              </a:ln>
+              <a:effectLst/>
+            </c:spPr>
             <c:txPr>
               <a:bodyPr/>
               <a:lstStyle/>
               <a:p>
                 <a:pPr>
-                  <a:defRPr b="0" i="0" strike="noStrike" sz="900" u="none">
+                  <a:defRPr sz="900" b="0" i="0" u="none" strike="noStrike">
                     <a:solidFill>
                       <a:srgbClr val="141B2E"/>
                     </a:solidFill>
                     <a:latin typeface="Arial"/>
                   </a:defRPr>
                 </a:pPr>
+                <a:endParaRPr lang="en-US"/>
               </a:p>
             </c:txPr>
             <c:showLegendKey val="0"/>
@@ -298,31 +328,34 @@
             <c:showPercent val="0"/>
             <c:showBubbleSize val="0"/>
             <c:showLeaderLines val="0"/>
+            <c:extLst>
+              <c:ext xmlns:c15="http://schemas.microsoft.com/office/drawing/2012/chart" uri="{CE6537A1-D6FC-4f65-9D91-7224C49458BB}">
+                <c15:showLeaderLines val="0"/>
+              </c:ext>
+            </c:extLst>
           </c:dLbls>
           <c:cat>
-            <c:multiLvlStrRef>
+            <c:strRef>
               <c:f>Sheet1!$A$2:$A$6</c:f>
-              <c:multiLvlStrCache>
+              <c:strCache>
                 <c:ptCount val="5"/>
-                <c:lvl>
-                  <c:pt idx="0">
-                    <c:v>Port scan</c:v>
-                  </c:pt>
-                  <c:pt idx="1">
-                    <c:v>Brute force</c:v>
-                  </c:pt>
-                  <c:pt idx="2">
-                    <c:v>DoS</c:v>
-                  </c:pt>
-                  <c:pt idx="3">
-                    <c:v>Exfiltration</c:v>
-                  </c:pt>
-                  <c:pt idx="4">
-                    <c:v>Lateral movement</c:v>
-                  </c:pt>
-                </c:lvl>
-              </c:multiLvlStrCache>
-            </c:multiLvlStrRef>
+                <c:pt idx="0">
+                  <c:v>Port scan</c:v>
+                </c:pt>
+                <c:pt idx="1">
+                  <c:v>Brute force</c:v>
+                </c:pt>
+                <c:pt idx="2">
+                  <c:v>DoS</c:v>
+                </c:pt>
+                <c:pt idx="3">
+                  <c:v>Exfiltration</c:v>
+                </c:pt>
+                <c:pt idx="4">
+                  <c:v>Lateral movement</c:v>
+                </c:pt>
+              </c:strCache>
+            </c:strRef>
           </c:cat>
           <c:val>
             <c:numRef>
@@ -334,13 +367,13 @@
                   <c:v>97.6</c:v>
                 </c:pt>
                 <c:pt idx="1">
-                  <c:v>37.8</c:v>
+                  <c:v>37.799999999999997</c:v>
                 </c:pt>
                 <c:pt idx="2">
-                  <c:v>68.4</c:v>
+                  <c:v>68.400000000000006</c:v>
                 </c:pt>
                 <c:pt idx="3">
-                  <c:v>64.9</c:v>
+                  <c:v>64.900000000000006</c:v>
                 </c:pt>
                 <c:pt idx="4">
                   <c:v>31</c:v>
@@ -348,36 +381,23 @@
               </c:numCache>
             </c:numRef>
           </c:val>
+          <c:extLst>
+            <c:ext xmlns:c16="http://schemas.microsoft.com/office/drawing/2014/chart" uri="{C3380CC4-5D6E-409C-BE32-E72D297353CC}">
+              <c16:uniqueId val="{00000001-4EEE-3E46-9274-97A9B688C4C7}"/>
+            </c:ext>
+          </c:extLst>
         </c:ser>
         <c:dLbls>
-          <c:numFmt formatCode="#,##0" sourceLinked="0"/>
-          <c:txPr>
-            <a:bodyPr/>
-            <a:lstStyle/>
-            <a:p>
-              <a:pPr>
-                <a:defRPr b="0" i="0" strike="noStrike" sz="900" u="none">
-                  <a:solidFill>
-                    <a:srgbClr val="141B2E"/>
-                  </a:solidFill>
-                  <a:latin typeface="Arial"/>
-                </a:defRPr>
-              </a:pPr>
-            </a:p>
-          </c:txPr>
           <c:showLegendKey val="0"/>
           <c:showVal val="1"/>
           <c:showCatName val="0"/>
           <c:showSerName val="0"/>
           <c:showPercent val="0"/>
           <c:showBubbleSize val="0"/>
-          <c:showLeaderLines val="0"/>
         </c:dLbls>
         <c:gapWidth val="150"/>
-        <c:overlap val="0"/>
         <c:axId val="2094734554"/>
         <c:axId val="2094734552"/>
-        <c:axId val="2094734556"/>
       </c:barChart>
       <c:catAx>
         <c:axId val="2094734554"/>
@@ -418,6 +438,7 @@
         <c:crosses val="autoZero"/>
         <c:auto val="1"/>
         <c:lblAlgn val="ctr"/>
+        <c:lblOffset val="100"/>
         <c:noMultiLvlLbl val="1"/>
       </c:catAx>
       <c:valAx>
@@ -487,7 +508,7 @@
         <a:lstStyle/>
         <a:p>
           <a:pPr>
-            <a:defRPr sz="1100">      </a:defRPr>
+            <a:defRPr sz="1100"/>
           </a:pPr>
           <a:endParaRPr lang="en-US"/>
         </a:p>
@@ -495,6 +516,7 @@
     </c:legend>
     <c:plotVisOnly val="1"/>
     <c:dispBlanksAs val="span"/>
+    <c:showDLblsOverMax val="1"/>
   </c:chart>
   <c:spPr>
     <a:noFill/>
@@ -510,9 +532,11 @@
 </file>
 
 <file path=ppt/charts/chart2.xml><?xml version="1.0" encoding="utf-8"?>
-<c:chartSpace xmlns:c="http://schemas.openxmlformats.org/drawingml/2006/chart" xmlns:a="http://schemas.openxmlformats.org/drawingml/2006/main" xmlns:r="http://schemas.openxmlformats.org/officeDocument/2006/relationships">
+<c:chartSpace xmlns:c="http://schemas.openxmlformats.org/drawingml/2006/chart" xmlns:a="http://schemas.openxmlformats.org/drawingml/2006/main" xmlns:r="http://schemas.openxmlformats.org/officeDocument/2006/relationships" xmlns:c16r2="http://schemas.microsoft.com/office/drawing/2015/06/chart">
   <c:date1904 val="0"/>
+  <c:lang val="en-GB"/>
   <c:roundedCorners val="1"/>
+  <c:style val="2"/>
   <c:chart>
     <c:title>
       <c:tx>
@@ -540,7 +564,6 @@
           </a:p>
         </c:rich>
       </c:tx>
-      <c:layout/>
       <c:overlay val="0"/>
     </c:title>
     <c:autoTitleDeleted val="0"/>
@@ -573,18 +596,26 @@
           <c:invertIfNegative val="0"/>
           <c:dLbls>
             <c:numFmt formatCode="0.00" sourceLinked="0"/>
+            <c:spPr>
+              <a:noFill/>
+              <a:ln>
+                <a:noFill/>
+              </a:ln>
+              <a:effectLst/>
+            </c:spPr>
             <c:txPr>
               <a:bodyPr/>
               <a:lstStyle/>
               <a:p>
                 <a:pPr>
-                  <a:defRPr b="0" i="0" strike="noStrike" sz="900" u="none">
+                  <a:defRPr sz="900" b="0" i="0" u="none" strike="noStrike">
                     <a:solidFill>
                       <a:srgbClr val="F5F7FA"/>
                     </a:solidFill>
                     <a:latin typeface="Arial"/>
                   </a:defRPr>
                 </a:pPr>
+                <a:endParaRPr lang="en-US"/>
               </a:p>
             </c:txPr>
             <c:showLegendKey val="0"/>
@@ -594,28 +625,31 @@
             <c:showPercent val="0"/>
             <c:showBubbleSize val="0"/>
             <c:showLeaderLines val="0"/>
+            <c:extLst>
+              <c:ext xmlns:c15="http://schemas.microsoft.com/office/drawing/2012/chart" uri="{CE6537A1-D6FC-4f65-9D91-7224C49458BB}">
+                <c15:showLeaderLines val="0"/>
+              </c:ext>
+            </c:extLst>
           </c:dLbls>
           <c:cat>
-            <c:multiLvlStrRef>
+            <c:strRef>
               <c:f>Sheet1!$A$2:$A$5</c:f>
-              <c:multiLvlStrCache>
+              <c:strCache>
                 <c:ptCount val="4"/>
-                <c:lvl>
-                  <c:pt idx="0">
-                    <c:v>ROC-AUC</c:v>
-                  </c:pt>
-                  <c:pt idx="1">
-                    <c:v>PR-AUC</c:v>
-                  </c:pt>
-                  <c:pt idx="2">
-                    <c:v>Precision</c:v>
-                  </c:pt>
-                  <c:pt idx="3">
-                    <c:v>Recall</c:v>
-                  </c:pt>
-                </c:lvl>
-              </c:multiLvlStrCache>
-            </c:multiLvlStrRef>
+                <c:pt idx="0">
+                  <c:v>ROC-AUC</c:v>
+                </c:pt>
+                <c:pt idx="1">
+                  <c:v>PR-AUC</c:v>
+                </c:pt>
+                <c:pt idx="2">
+                  <c:v>Precision</c:v>
+                </c:pt>
+                <c:pt idx="3">
+                  <c:v>Recall</c:v>
+                </c:pt>
+              </c:strCache>
+            </c:strRef>
           </c:cat>
           <c:val>
             <c:numRef>
@@ -627,17 +661,22 @@
                   <c:v>0.99</c:v>
                 </c:pt>
                 <c:pt idx="1">
-                  <c:v>0.896</c:v>
+                  <c:v>0.89600000000000002</c:v>
                 </c:pt>
                 <c:pt idx="2">
-                  <c:v>0.787</c:v>
+                  <c:v>0.78700000000000003</c:v>
                 </c:pt>
                 <c:pt idx="3">
-                  <c:v>0.829</c:v>
+                  <c:v>0.82899999999999996</c:v>
                 </c:pt>
               </c:numCache>
             </c:numRef>
           </c:val>
+          <c:extLst>
+            <c:ext xmlns:c16="http://schemas.microsoft.com/office/drawing/2014/chart" uri="{C3380CC4-5D6E-409C-BE32-E72D297353CC}">
+              <c16:uniqueId val="{00000000-87B5-B04A-A0D0-5A6831CA11F0}"/>
+            </c:ext>
+          </c:extLst>
         </c:ser>
         <c:ser>
           <c:idx val="1"/>
@@ -662,18 +701,26 @@
           <c:invertIfNegative val="0"/>
           <c:dLbls>
             <c:numFmt formatCode="0.00" sourceLinked="0"/>
+            <c:spPr>
+              <a:noFill/>
+              <a:ln>
+                <a:noFill/>
+              </a:ln>
+              <a:effectLst/>
+            </c:spPr>
             <c:txPr>
               <a:bodyPr/>
               <a:lstStyle/>
               <a:p>
                 <a:pPr>
-                  <a:defRPr b="0" i="0" strike="noStrike" sz="900" u="none">
+                  <a:defRPr sz="900" b="0" i="0" u="none" strike="noStrike">
                     <a:solidFill>
                       <a:srgbClr val="F5F7FA"/>
                     </a:solidFill>
                     <a:latin typeface="Arial"/>
                   </a:defRPr>
                 </a:pPr>
+                <a:endParaRPr lang="en-US"/>
               </a:p>
             </c:txPr>
             <c:showLegendKey val="0"/>
@@ -683,28 +730,31 @@
             <c:showPercent val="0"/>
             <c:showBubbleSize val="0"/>
             <c:showLeaderLines val="0"/>
+            <c:extLst>
+              <c:ext xmlns:c15="http://schemas.microsoft.com/office/drawing/2012/chart" uri="{CE6537A1-D6FC-4f65-9D91-7224C49458BB}">
+                <c15:showLeaderLines val="0"/>
+              </c:ext>
+            </c:extLst>
           </c:dLbls>
           <c:cat>
-            <c:multiLvlStrRef>
+            <c:strRef>
               <c:f>Sheet1!$A$2:$A$5</c:f>
-              <c:multiLvlStrCache>
+              <c:strCache>
                 <c:ptCount val="4"/>
-                <c:lvl>
-                  <c:pt idx="0">
-                    <c:v>ROC-AUC</c:v>
-                  </c:pt>
-                  <c:pt idx="1">
-                    <c:v>PR-AUC</c:v>
-                  </c:pt>
-                  <c:pt idx="2">
-                    <c:v>Precision</c:v>
-                  </c:pt>
-                  <c:pt idx="3">
-                    <c:v>Recall</c:v>
-                  </c:pt>
-                </c:lvl>
-              </c:multiLvlStrCache>
-            </c:multiLvlStrRef>
+                <c:pt idx="0">
+                  <c:v>ROC-AUC</c:v>
+                </c:pt>
+                <c:pt idx="1">
+                  <c:v>PR-AUC</c:v>
+                </c:pt>
+                <c:pt idx="2">
+                  <c:v>Precision</c:v>
+                </c:pt>
+                <c:pt idx="3">
+                  <c:v>Recall</c:v>
+                </c:pt>
+              </c:strCache>
+            </c:strRef>
           </c:cat>
           <c:val>
             <c:numRef>
@@ -713,7 +763,7 @@
                 <c:formatCode>General</c:formatCode>
                 <c:ptCount val="4"/>
                 <c:pt idx="0">
-                  <c:v>0.809</c:v>
+                  <c:v>0.80900000000000005</c:v>
                 </c:pt>
                 <c:pt idx="1">
                   <c:v>0.251</c:v>
@@ -727,36 +777,23 @@
               </c:numCache>
             </c:numRef>
           </c:val>
+          <c:extLst>
+            <c:ext xmlns:c16="http://schemas.microsoft.com/office/drawing/2014/chart" uri="{C3380CC4-5D6E-409C-BE32-E72D297353CC}">
+              <c16:uniqueId val="{00000001-87B5-B04A-A0D0-5A6831CA11F0}"/>
+            </c:ext>
+          </c:extLst>
         </c:ser>
         <c:dLbls>
-          <c:numFmt formatCode="0.00" sourceLinked="0"/>
-          <c:txPr>
-            <a:bodyPr/>
-            <a:lstStyle/>
-            <a:p>
-              <a:pPr>
-                <a:defRPr b="0" i="0" strike="noStrike" sz="900" u="none">
-                  <a:solidFill>
-                    <a:srgbClr val="F5F7FA"/>
-                  </a:solidFill>
-                  <a:latin typeface="Arial"/>
-                </a:defRPr>
-              </a:pPr>
-            </a:p>
-          </c:txPr>
           <c:showLegendKey val="0"/>
           <c:showVal val="1"/>
           <c:showCatName val="0"/>
           <c:showSerName val="0"/>
           <c:showPercent val="0"/>
           <c:showBubbleSize val="0"/>
-          <c:showLeaderLines val="0"/>
         </c:dLbls>
         <c:gapWidth val="150"/>
-        <c:overlap val="0"/>
         <c:axId val="2094734554"/>
         <c:axId val="2094734552"/>
-        <c:axId val="2094734556"/>
       </c:barChart>
       <c:catAx>
         <c:axId val="2094734554"/>
@@ -797,13 +834,14 @@
         <c:crosses val="autoZero"/>
         <c:auto val="1"/>
         <c:lblAlgn val="ctr"/>
+        <c:lblOffset val="100"/>
         <c:noMultiLvlLbl val="1"/>
       </c:catAx>
       <c:valAx>
         <c:axId val="2094734552"/>
         <c:scaling>
           <c:orientation val="minMax"/>
-          <c:max val="1.1"/>
+          <c:max val="1.1000000000000001"/>
         </c:scaling>
         <c:delete val="0"/>
         <c:axPos val="l"/>
@@ -880,6 +918,7 @@
     </c:legend>
     <c:plotVisOnly val="1"/>
     <c:dispBlanksAs val="span"/>
+    <c:showDLblsOverMax val="1"/>
   </c:chart>
   <c:spPr>
     <a:solidFill>
@@ -918,234 +957,10 @@
           <a:chExt cx="0" cy="0"/>
         </a:xfrm>
       </p:grpSpPr>
-      <p:sp>
-        <p:nvSpPr>
-          <p:cNvPr id="2" name="Header Placeholder 1"/>
-          <p:cNvSpPr>
-            <a:spLocks noGrp="1"/>
-          </p:cNvSpPr>
-          <p:nvPr>
-            <p:ph type="hdr" sz="quarter"/>
-          </p:nvPr>
-        </p:nvSpPr>
-        <p:spPr>
-          <a:xfrm>
-            <a:off x="0" y="0"/>
-            <a:ext cx="2971800" cy="458788"/>
-          </a:xfrm>
-          <a:prstGeom prst="rect">
-            <a:avLst/>
-          </a:prstGeom>
-        </p:spPr>
-        <p:txBody>
-          <a:bodyPr vert="horz" lIns="91440" tIns="45720" rIns="91440" bIns="45720" rtlCol="0"/>
-          <a:lstStyle>
-            <a:lvl1pPr algn="l">
-              <a:defRPr sz="1200"/>
-            </a:lvl1pPr>
-          </a:lstStyle>
-          <a:p>
-            <a:endParaRPr lang="en-US"/>
-          </a:p>
-        </p:txBody>
-      </p:sp>
-      <p:sp>
-        <p:nvSpPr>
-          <p:cNvPr id="3" name="Date Placeholder 2"/>
-          <p:cNvSpPr>
-            <a:spLocks noGrp="1"/>
-          </p:cNvSpPr>
-          <p:nvPr>
-            <p:ph type="dt" idx="1"/>
-          </p:nvPr>
-        </p:nvSpPr>
-        <p:spPr>
-          <a:xfrm>
-            <a:off x="3884613" y="0"/>
-            <a:ext cx="2971800" cy="458788"/>
-          </a:xfrm>
-          <a:prstGeom prst="rect">
-            <a:avLst/>
-          </a:prstGeom>
-        </p:spPr>
-        <p:txBody>
-          <a:bodyPr vert="horz" lIns="91440" tIns="45720" rIns="91440" bIns="45720" rtlCol="0"/>
-          <a:lstStyle>
-            <a:lvl1pPr algn="r">
-              <a:defRPr sz="1200"/>
-            </a:lvl1pPr>
-          </a:lstStyle>
-          <a:p>
-            <a:fld id="{5282F153-3F37-0F45-9E97-73ACFA13230C}" type="datetimeFigureOut">
-              <a:rPr lang="en-US"/>
-              <a:t>7/23/19</a:t>
-            </a:fld>
-            <a:endParaRPr lang="en-US"/>
-          </a:p>
-        </p:txBody>
-      </p:sp>
-      <p:sp>
-        <p:nvSpPr>
-          <p:cNvPr id="4" name="Slide Image Placeholder 3"/>
-          <p:cNvSpPr>
-            <a:spLocks noGrp="1" noRot="1" noChangeAspect="1"/>
-          </p:cNvSpPr>
-          <p:nvPr>
-            <p:ph type="sldImg" idx="2"/>
-          </p:nvPr>
-        </p:nvSpPr>
-        <p:spPr>
-          <a:xfrm>
-            <a:off x="685800" y="1143000"/>
-            <a:ext cx="5486400" cy="3086100"/>
-          </a:xfrm>
-          <a:prstGeom prst="rect">
-            <a:avLst/>
-          </a:prstGeom>
-          <a:noFill/>
-          <a:ln w="12700">
-            <a:solidFill>
-              <a:prstClr val="black"/>
-            </a:solidFill>
-          </a:ln>
-        </p:spPr>
-        <p:txBody>
-          <a:bodyPr vert="horz" lIns="91440" tIns="45720" rIns="91440" bIns="45720" rtlCol="0" anchor="ctr"/>
-          <a:lstStyle/>
-          <a:p>
-            <a:endParaRPr lang="en-US"/>
-          </a:p>
-        </p:txBody>
-      </p:sp>
-      <p:sp>
-        <p:nvSpPr>
-          <p:cNvPr id="5" name="Notes Placeholder 4"/>
-          <p:cNvSpPr>
-            <a:spLocks noGrp="1"/>
-          </p:cNvSpPr>
-          <p:nvPr>
-            <p:ph type="body" sz="quarter" idx="3"/>
-          </p:nvPr>
-        </p:nvSpPr>
-        <p:spPr>
-          <a:xfrm>
-            <a:off x="685800" y="4400550"/>
-            <a:ext cx="5486400" cy="3600450"/>
-          </a:xfrm>
-          <a:prstGeom prst="rect">
-            <a:avLst/>
-          </a:prstGeom>
-        </p:spPr>
-        <p:txBody>
-          <a:bodyPr vert="horz" lIns="91440" tIns="45720" rIns="91440" bIns="45720" rtlCol="0"/>
-          <a:lstStyle/>
-          <a:p>
-            <a:pPr lvl="0"/>
-            <a:r>
-              <a:rPr lang="en-US"/>
-              <a:t>Click to edit Master text styles</a:t>
-            </a:r>
-          </a:p>
-          <a:p>
-            <a:pPr lvl="1"/>
-            <a:r>
-              <a:rPr lang="en-US"/>
-              <a:t>Second level</a:t>
-            </a:r>
-          </a:p>
-          <a:p>
-            <a:pPr lvl="2"/>
-            <a:r>
-              <a:rPr lang="en-US"/>
-              <a:t>Third level</a:t>
-            </a:r>
-          </a:p>
-          <a:p>
-            <a:pPr lvl="3"/>
-            <a:r>
-              <a:rPr lang="en-US"/>
-              <a:t>Fourth level</a:t>
-            </a:r>
-          </a:p>
-          <a:p>
-            <a:pPr lvl="4"/>
-            <a:r>
-              <a:rPr lang="en-US"/>
-              <a:t>Fifth level</a:t>
-            </a:r>
-          </a:p>
-        </p:txBody>
-      </p:sp>
-      <p:sp>
-        <p:nvSpPr>
-          <p:cNvPr id="6" name="Footer Placeholder 5"/>
-          <p:cNvSpPr>
-            <a:spLocks noGrp="1"/>
-          </p:cNvSpPr>
-          <p:nvPr>
-            <p:ph type="ftr" sz="quarter" idx="4"/>
-          </p:nvPr>
-        </p:nvSpPr>
-        <p:spPr>
-          <a:xfrm>
-            <a:off x="0" y="8685213"/>
-            <a:ext cx="2971800" cy="458787"/>
-          </a:xfrm>
-          <a:prstGeom prst="rect">
-            <a:avLst/>
-          </a:prstGeom>
-        </p:spPr>
-        <p:txBody>
-          <a:bodyPr vert="horz" lIns="91440" tIns="45720" rIns="91440" bIns="45720" rtlCol="0" anchor="b"/>
-          <a:lstStyle>
-            <a:lvl1pPr algn="l">
-              <a:defRPr sz="1200"/>
-            </a:lvl1pPr>
-          </a:lstStyle>
-          <a:p>
-            <a:endParaRPr lang="en-US"/>
-          </a:p>
-        </p:txBody>
-      </p:sp>
-      <p:sp>
-        <p:nvSpPr>
-          <p:cNvPr id="7" name="Slide Number Placeholder 6"/>
-          <p:cNvSpPr>
-            <a:spLocks noGrp="1"/>
-          </p:cNvSpPr>
-          <p:nvPr>
-            <p:ph type="sldNum" sz="quarter" idx="5"/>
-          </p:nvPr>
-        </p:nvSpPr>
-        <p:spPr>
-          <a:xfrm>
-            <a:off x="3884613" y="8685213"/>
-            <a:ext cx="2971800" cy="458787"/>
-          </a:xfrm>
-          <a:prstGeom prst="rect">
-            <a:avLst/>
-          </a:prstGeom>
-        </p:spPr>
-        <p:txBody>
-          <a:bodyPr vert="horz" lIns="91440" tIns="45720" rIns="91440" bIns="45720" rtlCol="0" anchor="b"/>
-          <a:lstStyle>
-            <a:lvl1pPr algn="r">
-              <a:defRPr sz="1200"/>
-            </a:lvl1pPr>
-          </a:lstStyle>
-          <a:p>
-            <a:fld id="{CE5E9CC1-C706-0F49-92D6-E571CC5EEA8F}" type="slidenum">
-              <a:rPr lang="en-US"/>
-              <a:t>‹#›</a:t>
-            </a:fld>
-            <a:endParaRPr lang="en-US"/>
-          </a:p>
-        </p:txBody>
-      </p:sp>
     </p:spTree>
     <p:extLst>
       <p:ext uri="{BB962C8B-B14F-4D97-AF65-F5344CB8AC3E}">
-        <p14:creationId xmlns:p14="http://schemas.microsoft.com/office/powerpoint/2010/main" val="1024086991"/>
+        <p14:creationId xmlns:p14="http://schemas.microsoft.com/office/powerpoint/2010/main" val="917685002"/>
       </p:ext>
     </p:extLst>
   </p:cSld>
@@ -1289,10 +1104,6 @@
           <a:bodyPr/>
           <a:lstStyle/>
           <a:p>
-            <a:r>
-              <a:rPr lang="en-US" dirty="0"/>
-              <a:t/>
-            </a:r>
             <a:endParaRPr lang="en-US" dirty="0"/>
           </a:p>
         </p:txBody>
@@ -1377,10 +1188,6 @@
           <a:bodyPr/>
           <a:lstStyle/>
           <a:p>
-            <a:r>
-              <a:rPr lang="en-US" dirty="0"/>
-              <a:t/>
-            </a:r>
             <a:endParaRPr lang="en-US" dirty="0"/>
           </a:p>
         </p:txBody>
@@ -1465,10 +1272,6 @@
           <a:bodyPr/>
           <a:lstStyle/>
           <a:p>
-            <a:r>
-              <a:rPr lang="en-US" dirty="0"/>
-              <a:t/>
-            </a:r>
             <a:endParaRPr lang="en-US" dirty="0"/>
           </a:p>
         </p:txBody>
@@ -1553,10 +1356,6 @@
           <a:bodyPr/>
           <a:lstStyle/>
           <a:p>
-            <a:r>
-              <a:rPr lang="en-US" dirty="0"/>
-              <a:t/>
-            </a:r>
             <a:endParaRPr lang="en-US" dirty="0"/>
           </a:p>
         </p:txBody>
@@ -1641,10 +1440,6 @@
           <a:bodyPr/>
           <a:lstStyle/>
           <a:p>
-            <a:r>
-              <a:rPr lang="en-US" dirty="0"/>
-              <a:t/>
-            </a:r>
             <a:endParaRPr lang="en-US" dirty="0"/>
           </a:p>
         </p:txBody>
@@ -1729,10 +1524,6 @@
           <a:bodyPr/>
           <a:lstStyle/>
           <a:p>
-            <a:r>
-              <a:rPr lang="en-US" dirty="0"/>
-              <a:t/>
-            </a:r>
             <a:endParaRPr lang="en-US" dirty="0"/>
           </a:p>
         </p:txBody>
@@ -1817,10 +1608,6 @@
           <a:bodyPr/>
           <a:lstStyle/>
           <a:p>
-            <a:r>
-              <a:rPr lang="en-US" dirty="0"/>
-              <a:t/>
-            </a:r>
             <a:endParaRPr lang="en-US" dirty="0"/>
           </a:p>
         </p:txBody>
@@ -1905,10 +1692,6 @@
           <a:bodyPr/>
           <a:lstStyle/>
           <a:p>
-            <a:r>
-              <a:rPr lang="en-US" dirty="0"/>
-              <a:t/>
-            </a:r>
             <a:endParaRPr lang="en-US" dirty="0"/>
           </a:p>
         </p:txBody>
@@ -1993,10 +1776,6 @@
           <a:bodyPr/>
           <a:lstStyle/>
           <a:p>
-            <a:r>
-              <a:rPr lang="en-US" dirty="0"/>
-              <a:t/>
-            </a:r>
             <a:endParaRPr lang="en-US" dirty="0"/>
           </a:p>
         </p:txBody>
@@ -2081,10 +1860,6 @@
           <a:bodyPr/>
           <a:lstStyle/>
           <a:p>
-            <a:r>
-              <a:rPr lang="en-US" dirty="0"/>
-              <a:t/>
-            </a:r>
             <a:endParaRPr lang="en-US" dirty="0"/>
           </a:p>
         </p:txBody>
@@ -2169,10 +1944,6 @@
           <a:bodyPr/>
           <a:lstStyle/>
           <a:p>
-            <a:r>
-              <a:rPr lang="en-US" dirty="0"/>
-              <a:t/>
-            </a:r>
             <a:endParaRPr lang="en-US" dirty="0"/>
           </a:p>
         </p:txBody>
@@ -2257,10 +2028,6 @@
           <a:bodyPr/>
           <a:lstStyle/>
           <a:p>
-            <a:r>
-              <a:rPr lang="en-US" dirty="0"/>
-              <a:t/>
-            </a:r>
             <a:endParaRPr lang="en-US" dirty="0"/>
           </a:p>
         </p:txBody>
@@ -2334,6 +2101,11 @@
 <file path=ppt/slideMasters/slideMaster1.xml><?xml version="1.0" encoding="utf-8"?>
 <p:sldMaster xmlns:a="http://schemas.openxmlformats.org/drawingml/2006/main" xmlns:r="http://schemas.openxmlformats.org/officeDocument/2006/relationships" xmlns:p="http://schemas.openxmlformats.org/presentationml/2006/main">
   <p:cSld>
+    <p:bg>
+      <p:bgRef idx="1001">
+        <a:schemeClr val="bg1"/>
+      </p:bgRef>
+    </p:bg>
     <p:spTree>
       <p:nvGrpSpPr>
         <p:cNvPr id="1" name=""/>
@@ -2616,6 +2388,7 @@
         <a:solidFill>
           <a:srgbClr val="0B0F1E"/>
         </a:solidFill>
+        <a:effectLst/>
       </p:bgPr>
     </p:bg>
     <p:spTree>
@@ -3971,11 +3744,11 @@
           <a:bodyPr wrap="square" lIns="0" tIns="0" rIns="0" bIns="0" rtlCol="0" anchor="ctr"/>
           <a:lstStyle/>
           <a:p>
-            <a:pPr indent="0" marL="0">
-              <a:buNone/>
-            </a:pPr>
-            <a:r>
-              <a:rPr lang="en-US" sz="1300" b="1" spc="200" kern="0" dirty="0">
+            <a:pPr marL="0" indent="0">
+              <a:buNone/>
+            </a:pPr>
+            <a:r>
+              <a:rPr lang="en-US" sz="1300" b="1" kern="0" spc="200" dirty="0">
                 <a:solidFill>
                   <a:srgbClr val="00D1B2"/>
                 </a:solidFill>
@@ -4010,7 +3783,7 @@
           <a:bodyPr wrap="square" lIns="0" tIns="0" rIns="0" bIns="0" rtlCol="0" anchor="ctr"/>
           <a:lstStyle/>
           <a:p>
-            <a:pPr indent="0" marL="0">
+            <a:pPr marL="0" indent="0">
               <a:buNone/>
             </a:pPr>
             <a:r>
@@ -4049,7 +3822,7 @@
           <a:bodyPr wrap="square" lIns="0" tIns="0" rIns="0" bIns="0" rtlCol="0" anchor="ctr"/>
           <a:lstStyle/>
           <a:p>
-            <a:pPr indent="0" marL="0">
+            <a:pPr marL="0" indent="0">
               <a:buNone/>
             </a:pPr>
             <a:r>
@@ -4088,7 +3861,7 @@
           <a:bodyPr wrap="square" lIns="0" tIns="0" rIns="0" bIns="0" rtlCol="0" anchor="ctr"/>
           <a:lstStyle/>
           <a:p>
-            <a:pPr indent="0" marL="0">
+            <a:pPr marL="0" indent="0">
               <a:buNone/>
             </a:pPr>
             <a:r>
@@ -4150,7 +3923,7 @@
           <a:bodyPr wrap="square" lIns="0" tIns="0" rIns="0" bIns="0" rtlCol="0" anchor="ctr"/>
           <a:lstStyle/>
           <a:p>
-            <a:pPr indent="0" marL="0">
+            <a:pPr marL="0" indent="0">
               <a:buNone/>
             </a:pPr>
             <a:r>
@@ -4189,7 +3962,7 @@
           <a:bodyPr wrap="square" lIns="0" tIns="0" rIns="0" bIns="0" rtlCol="0" anchor="ctr"/>
           <a:lstStyle/>
           <a:p>
-            <a:pPr indent="0" marL="0">
+            <a:pPr marL="0" indent="0">
               <a:buNone/>
             </a:pPr>
             <a:r>
@@ -4201,7 +3974,7 @@
                 <a:ea typeface="Calibri" pitchFamily="34" charset="-122"/>
                 <a:cs typeface="Calibri" pitchFamily="34" charset="-120"/>
               </a:rPr>
-              <a:t>Mohammed Shameer R S</a:t>
+              <a:t>Fida M S</a:t>
             </a:r>
             <a:endParaRPr lang="en-US" sz="1300" dirty="0"/>
           </a:p>
@@ -4223,6 +3996,7 @@
         <a:solidFill>
           <a:srgbClr val="FFFFFF"/>
         </a:solidFill>
+        <a:effectLst/>
       </p:bgPr>
     </p:bg>
     <p:spTree>
@@ -4260,11 +4034,11 @@
           <a:bodyPr wrap="square" lIns="0" tIns="0" rIns="0" bIns="0" rtlCol="0" anchor="ctr"/>
           <a:lstStyle/>
           <a:p>
-            <a:pPr algn="l" indent="0" marL="0">
-              <a:buNone/>
-            </a:pPr>
-            <a:r>
-              <a:rPr lang="en-US" sz="1200" b="1" spc="200" kern="0" dirty="0">
+            <a:pPr marL="0" indent="0" algn="l">
+              <a:buNone/>
+            </a:pPr>
+            <a:r>
+              <a:rPr lang="en-US" sz="1200" b="1" kern="0" spc="200" dirty="0">
                 <a:solidFill>
                   <a:srgbClr val="0A8F7C"/>
                 </a:solidFill>
@@ -4299,7 +4073,7 @@
           <a:bodyPr wrap="square" lIns="0" tIns="0" rIns="0" bIns="0" rtlCol="0" anchor="ctr"/>
           <a:lstStyle/>
           <a:p>
-            <a:pPr algn="l" indent="0" marL="0">
+            <a:pPr marL="0" indent="0" algn="l">
               <a:buNone/>
             </a:pPr>
             <a:r>
@@ -4360,7 +4134,7 @@
           <a:bodyPr wrap="square" lIns="0" tIns="0" rIns="0" bIns="0" rtlCol="0" anchor="ctr"/>
           <a:lstStyle/>
           <a:p>
-            <a:pPr algn="ctr" indent="0" marL="0">
+            <a:pPr marL="0" indent="0" algn="ctr">
               <a:buNone/>
             </a:pPr>
             <a:r>
@@ -4399,7 +4173,7 @@
           <a:bodyPr wrap="square" lIns="0" tIns="0" rIns="0" bIns="0" rtlCol="0" anchor="ctr"/>
           <a:lstStyle/>
           <a:p>
-            <a:pPr algn="ctr" indent="0" marL="0">
+            <a:pPr marL="0" indent="0" algn="ctr">
               <a:buNone/>
             </a:pPr>
             <a:r>
@@ -4438,7 +4212,7 @@
           <a:bodyPr wrap="square" lIns="0" tIns="0" rIns="0" bIns="0" rtlCol="0" anchor="ctr"/>
           <a:lstStyle/>
           <a:p>
-            <a:pPr algn="ctr" indent="0" marL="0">
+            <a:pPr marL="0" indent="0" algn="ctr">
               <a:buNone/>
             </a:pPr>
             <a:r>
@@ -4500,7 +4274,7 @@
           <a:bodyPr wrap="square" lIns="0" tIns="0" rIns="0" bIns="0" rtlCol="0" anchor="ctr"/>
           <a:lstStyle/>
           <a:p>
-            <a:pPr indent="0" marL="0">
+            <a:pPr marL="0" indent="0">
               <a:buNone/>
             </a:pPr>
             <a:r>
@@ -4539,7 +4313,7 @@
           <a:bodyPr wrap="square" lIns="0" tIns="0" rIns="0" bIns="0" rtlCol="0" anchor="ctr"/>
           <a:lstStyle/>
           <a:p>
-            <a:pPr indent="0" marL="0">
+            <a:pPr marL="0" indent="0">
               <a:buNone/>
             </a:pPr>
             <a:r>
@@ -4578,7 +4352,7 @@
           <a:bodyPr wrap="square" lIns="0" tIns="0" rIns="0" bIns="0" rtlCol="0" anchor="ctr"/>
           <a:lstStyle/>
           <a:p>
-            <a:pPr algn="r" indent="0" marL="0">
+            <a:pPr marL="0" indent="0" algn="r">
               <a:buNone/>
             </a:pPr>
             <a:r>
@@ -4617,7 +4391,7 @@
           <a:bodyPr wrap="square" lIns="0" tIns="0" rIns="0" bIns="0" rtlCol="0" anchor="ctr"/>
           <a:lstStyle/>
           <a:p>
-            <a:pPr indent="0" marL="0">
+            <a:pPr marL="0" indent="0">
               <a:buNone/>
             </a:pPr>
             <a:r>
@@ -4656,7 +4430,7 @@
           <a:bodyPr wrap="square" lIns="0" tIns="0" rIns="0" bIns="0" rtlCol="0" anchor="ctr"/>
           <a:lstStyle/>
           <a:p>
-            <a:pPr algn="r" indent="0" marL="0">
+            <a:pPr marL="0" indent="0" algn="r">
               <a:buNone/>
             </a:pPr>
             <a:r>
@@ -4695,7 +4469,7 @@
           <a:bodyPr wrap="square" lIns="0" tIns="0" rIns="0" bIns="0" rtlCol="0" anchor="ctr"/>
           <a:lstStyle/>
           <a:p>
-            <a:pPr indent="0" marL="0">
+            <a:pPr marL="0" indent="0">
               <a:buNone/>
             </a:pPr>
             <a:r>
@@ -4734,7 +4508,7 @@
           <a:bodyPr wrap="square" lIns="0" tIns="0" rIns="0" bIns="0" rtlCol="0" anchor="ctr"/>
           <a:lstStyle/>
           <a:p>
-            <a:pPr algn="r" indent="0" marL="0">
+            <a:pPr marL="0" indent="0" algn="r">
               <a:buNone/>
             </a:pPr>
             <a:r>
@@ -4773,7 +4547,7 @@
           <a:bodyPr wrap="square" lIns="0" tIns="0" rIns="0" bIns="0" rtlCol="0" anchor="ctr"/>
           <a:lstStyle/>
           <a:p>
-            <a:pPr indent="0" marL="0">
+            <a:pPr marL="0" indent="0">
               <a:buNone/>
             </a:pPr>
             <a:r>
@@ -4812,7 +4586,7 @@
           <a:bodyPr wrap="square" lIns="0" tIns="0" rIns="0" bIns="0" rtlCol="0" anchor="ctr"/>
           <a:lstStyle/>
           <a:p>
-            <a:pPr algn="r" indent="0" marL="0">
+            <a:pPr marL="0" indent="0" algn="r">
               <a:buNone/>
             </a:pPr>
             <a:r>
@@ -4851,7 +4625,7 @@
           <a:bodyPr wrap="square" lIns="0" tIns="0" rIns="0" bIns="0" rtlCol="0" anchor="ctr"/>
           <a:lstStyle/>
           <a:p>
-            <a:pPr indent="0" marL="0">
+            <a:pPr marL="0" indent="0">
               <a:buNone/>
             </a:pPr>
             <a:r>
@@ -4890,7 +4664,7 @@
           <a:bodyPr wrap="square" lIns="0" tIns="0" rIns="0" bIns="0" rtlCol="0" anchor="ctr"/>
           <a:lstStyle/>
           <a:p>
-            <a:pPr algn="r" indent="0" marL="0">
+            <a:pPr marL="0" indent="0" algn="r">
               <a:buNone/>
             </a:pPr>
             <a:r>
@@ -4951,7 +4725,7 @@
           <a:bodyPr wrap="square" lIns="0" tIns="0" rIns="0" bIns="0" rtlCol="0" anchor="ctr"/>
           <a:lstStyle/>
           <a:p>
-            <a:pPr indent="0" marL="0">
+            <a:pPr marL="0" indent="0">
               <a:buNone/>
             </a:pPr>
             <a:r>
@@ -4990,7 +4764,7 @@
           <a:bodyPr wrap="square" lIns="0" tIns="0" rIns="0" bIns="0" rtlCol="0" anchor="t"/>
           <a:lstStyle/>
           <a:p>
-            <a:pPr indent="0" marL="0">
+            <a:pPr marL="0" indent="0">
               <a:buNone/>
             </a:pPr>
             <a:r>
@@ -5007,13 +4781,13 @@
             <a:endParaRPr lang="en-US" sz="1200" dirty="0"/>
           </a:p>
           <a:p>
-            <a:pPr indent="0" marL="0">
+            <a:pPr marL="0" indent="0">
               <a:buNone/>
             </a:pPr>
             <a:endParaRPr lang="en-US" sz="1200" dirty="0"/>
           </a:p>
           <a:p>
-            <a:pPr indent="0" marL="0">
+            <a:pPr marL="0" indent="0">
               <a:buNone/>
             </a:pPr>
             <a:r>
@@ -5030,13 +4804,13 @@
             <a:endParaRPr lang="en-US" sz="1200" dirty="0"/>
           </a:p>
           <a:p>
-            <a:pPr indent="0" marL="0">
+            <a:pPr marL="0" indent="0">
               <a:buNone/>
             </a:pPr>
             <a:endParaRPr lang="en-US" sz="1200" dirty="0"/>
           </a:p>
           <a:p>
-            <a:pPr indent="0" marL="0">
+            <a:pPr marL="0" indent="0">
               <a:buNone/>
             </a:pPr>
             <a:r>
@@ -5053,13 +4827,13 @@
             <a:endParaRPr lang="en-US" sz="1200" dirty="0"/>
           </a:p>
           <a:p>
-            <a:pPr indent="0" marL="0">
+            <a:pPr marL="0" indent="0">
               <a:buNone/>
             </a:pPr>
             <a:endParaRPr lang="en-US" sz="1200" dirty="0"/>
           </a:p>
           <a:p>
-            <a:pPr indent="0" marL="0">
+            <a:pPr marL="0" indent="0">
               <a:buNone/>
             </a:pPr>
             <a:r>
@@ -5098,7 +4872,7 @@
           <a:bodyPr wrap="square" lIns="0" tIns="0" rIns="0" bIns="0" rtlCol="0" anchor="ctr"/>
           <a:lstStyle/>
           <a:p>
-            <a:pPr algn="r" indent="0" marL="0">
+            <a:pPr marL="0" indent="0" algn="r">
               <a:buNone/>
             </a:pPr>
             <a:r>
@@ -5132,6 +4906,7 @@
         <a:solidFill>
           <a:srgbClr val="0B0F1E"/>
         </a:solidFill>
+        <a:effectLst/>
       </p:bgPr>
     </p:bg>
     <p:spTree>
@@ -5169,11 +4944,11 @@
           <a:bodyPr wrap="square" lIns="0" tIns="0" rIns="0" bIns="0" rtlCol="0" anchor="ctr"/>
           <a:lstStyle/>
           <a:p>
-            <a:pPr algn="l" indent="0" marL="0">
-              <a:buNone/>
-            </a:pPr>
-            <a:r>
-              <a:rPr lang="en-US" sz="1200" b="1" spc="200" kern="0" dirty="0">
+            <a:pPr marL="0" indent="0" algn="l">
+              <a:buNone/>
+            </a:pPr>
+            <a:r>
+              <a:rPr lang="en-US" sz="1200" b="1" kern="0" spc="200" dirty="0">
                 <a:solidFill>
                   <a:srgbClr val="00D1B2"/>
                 </a:solidFill>
@@ -5208,7 +4983,7 @@
           <a:bodyPr wrap="square" lIns="0" tIns="0" rIns="0" bIns="0" rtlCol="0" anchor="ctr"/>
           <a:lstStyle/>
           <a:p>
-            <a:pPr algn="l" indent="0" marL="0">
+            <a:pPr marL="0" indent="0" algn="l">
               <a:buNone/>
             </a:pPr>
             <a:r>
@@ -5274,7 +5049,7 @@
           <a:bodyPr wrap="square" lIns="0" tIns="0" rIns="0" bIns="0" rtlCol="0" anchor="ctr"/>
           <a:lstStyle/>
           <a:p>
-            <a:pPr algn="ctr" indent="0" marL="0">
+            <a:pPr marL="0" indent="0" algn="ctr">
               <a:buNone/>
             </a:pPr>
             <a:r>
@@ -5313,7 +5088,7 @@
           <a:bodyPr wrap="square" lIns="0" tIns="0" rIns="0" bIns="0" rtlCol="0" anchor="ctr"/>
           <a:lstStyle/>
           <a:p>
-            <a:pPr indent="0" marL="0">
+            <a:pPr marL="0" indent="0">
               <a:buNone/>
             </a:pPr>
             <a:r>
@@ -5352,7 +5127,7 @@
           <a:bodyPr wrap="square" lIns="0" tIns="0" rIns="0" bIns="0" rtlCol="0" anchor="ctr"/>
           <a:lstStyle/>
           <a:p>
-            <a:pPr indent="0" marL="0">
+            <a:pPr marL="0" indent="0">
               <a:buNone/>
             </a:pPr>
             <a:r>
@@ -5418,7 +5193,7 @@
           <a:bodyPr wrap="square" lIns="0" tIns="0" rIns="0" bIns="0" rtlCol="0" anchor="ctr"/>
           <a:lstStyle/>
           <a:p>
-            <a:pPr algn="ctr" indent="0" marL="0">
+            <a:pPr marL="0" indent="0" algn="ctr">
               <a:buNone/>
             </a:pPr>
             <a:r>
@@ -5457,7 +5232,7 @@
           <a:bodyPr wrap="square" lIns="0" tIns="0" rIns="0" bIns="0" rtlCol="0" anchor="ctr"/>
           <a:lstStyle/>
           <a:p>
-            <a:pPr indent="0" marL="0">
+            <a:pPr marL="0" indent="0">
               <a:buNone/>
             </a:pPr>
             <a:r>
@@ -5496,7 +5271,7 @@
           <a:bodyPr wrap="square" lIns="0" tIns="0" rIns="0" bIns="0" rtlCol="0" anchor="ctr"/>
           <a:lstStyle/>
           <a:p>
-            <a:pPr indent="0" marL="0">
+            <a:pPr marL="0" indent="0">
               <a:buNone/>
             </a:pPr>
             <a:r>
@@ -5562,7 +5337,7 @@
           <a:bodyPr wrap="square" lIns="0" tIns="0" rIns="0" bIns="0" rtlCol="0" anchor="ctr"/>
           <a:lstStyle/>
           <a:p>
-            <a:pPr algn="ctr" indent="0" marL="0">
+            <a:pPr marL="0" indent="0" algn="ctr">
               <a:buNone/>
             </a:pPr>
             <a:r>
@@ -5601,7 +5376,7 @@
           <a:bodyPr wrap="square" lIns="0" tIns="0" rIns="0" bIns="0" rtlCol="0" anchor="ctr"/>
           <a:lstStyle/>
           <a:p>
-            <a:pPr indent="0" marL="0">
+            <a:pPr marL="0" indent="0">
               <a:buNone/>
             </a:pPr>
             <a:r>
@@ -5640,7 +5415,7 @@
           <a:bodyPr wrap="square" lIns="0" tIns="0" rIns="0" bIns="0" rtlCol="0" anchor="ctr"/>
           <a:lstStyle/>
           <a:p>
-            <a:pPr indent="0" marL="0">
+            <a:pPr marL="0" indent="0">
               <a:buNone/>
             </a:pPr>
             <a:r>
@@ -5706,7 +5481,7 @@
           <a:bodyPr wrap="square" lIns="0" tIns="0" rIns="0" bIns="0" rtlCol="0" anchor="ctr"/>
           <a:lstStyle/>
           <a:p>
-            <a:pPr algn="ctr" indent="0" marL="0">
+            <a:pPr marL="0" indent="0" algn="ctr">
               <a:buNone/>
             </a:pPr>
             <a:r>
@@ -5745,7 +5520,7 @@
           <a:bodyPr wrap="square" lIns="0" tIns="0" rIns="0" bIns="0" rtlCol="0" anchor="ctr"/>
           <a:lstStyle/>
           <a:p>
-            <a:pPr indent="0" marL="0">
+            <a:pPr marL="0" indent="0">
               <a:buNone/>
             </a:pPr>
             <a:r>
@@ -5784,7 +5559,7 @@
           <a:bodyPr wrap="square" lIns="0" tIns="0" rIns="0" bIns="0" rtlCol="0" anchor="ctr"/>
           <a:lstStyle/>
           <a:p>
-            <a:pPr indent="0" marL="0">
+            <a:pPr marL="0" indent="0">
               <a:buNone/>
             </a:pPr>
             <a:r>
@@ -5850,7 +5625,7 @@
           <a:bodyPr wrap="square" lIns="0" tIns="0" rIns="0" bIns="0" rtlCol="0" anchor="ctr"/>
           <a:lstStyle/>
           <a:p>
-            <a:pPr algn="ctr" indent="0" marL="0">
+            <a:pPr marL="0" indent="0" algn="ctr">
               <a:buNone/>
             </a:pPr>
             <a:r>
@@ -5889,7 +5664,7 @@
           <a:bodyPr wrap="square" lIns="0" tIns="0" rIns="0" bIns="0" rtlCol="0" anchor="ctr"/>
           <a:lstStyle/>
           <a:p>
-            <a:pPr indent="0" marL="0">
+            <a:pPr marL="0" indent="0">
               <a:buNone/>
             </a:pPr>
             <a:r>
@@ -5928,7 +5703,7 @@
           <a:bodyPr wrap="square" lIns="0" tIns="0" rIns="0" bIns="0" rtlCol="0" anchor="ctr"/>
           <a:lstStyle/>
           <a:p>
-            <a:pPr indent="0" marL="0">
+            <a:pPr marL="0" indent="0">
               <a:buNone/>
             </a:pPr>
             <a:r>
@@ -5967,7 +5742,7 @@
           <a:bodyPr wrap="square" lIns="0" tIns="0" rIns="0" bIns="0" rtlCol="0" anchor="ctr"/>
           <a:lstStyle/>
           <a:p>
-            <a:pPr algn="r" indent="0" marL="0">
+            <a:pPr marL="0" indent="0" algn="r">
               <a:buNone/>
             </a:pPr>
             <a:r>
@@ -6001,6 +5776,7 @@
         <a:solidFill>
           <a:srgbClr val="0B0F1E"/>
         </a:solidFill>
+        <a:effectLst/>
       </p:bgPr>
     </p:bg>
     <p:spTree>
@@ -6918,11 +6694,11 @@
           <a:bodyPr wrap="square" lIns="0" tIns="0" rIns="0" bIns="0" rtlCol="0" anchor="ctr"/>
           <a:lstStyle/>
           <a:p>
-            <a:pPr indent="0" marL="0">
-              <a:buNone/>
-            </a:pPr>
-            <a:r>
-              <a:rPr lang="en-US" sz="1300" b="1" spc="200" kern="0" dirty="0">
+            <a:pPr marL="0" indent="0">
+              <a:buNone/>
+            </a:pPr>
+            <a:r>
+              <a:rPr lang="en-US" sz="1300" b="1" kern="0" spc="200" dirty="0">
                 <a:solidFill>
                   <a:srgbClr val="00D1B2"/>
                 </a:solidFill>
@@ -6957,7 +6733,7 @@
           <a:bodyPr wrap="square" lIns="0" tIns="0" rIns="0" bIns="0" rtlCol="0" anchor="ctr"/>
           <a:lstStyle/>
           <a:p>
-            <a:pPr indent="0" marL="0">
+            <a:pPr marL="0" indent="0">
               <a:buNone/>
             </a:pPr>
             <a:r>
@@ -6996,7 +6772,7 @@
           <a:bodyPr wrap="square" lIns="0" tIns="0" rIns="0" bIns="0" rtlCol="0" anchor="ctr"/>
           <a:lstStyle/>
           <a:p>
-            <a:pPr indent="0" marL="0">
+            <a:pPr marL="0" indent="0">
               <a:buNone/>
             </a:pPr>
             <a:r>
@@ -7058,7 +6834,7 @@
           <a:bodyPr wrap="square" lIns="0" tIns="0" rIns="0" bIns="0" rtlCol="0" anchor="ctr"/>
           <a:lstStyle/>
           <a:p>
-            <a:pPr indent="0" marL="0">
+            <a:pPr marL="0" indent="0">
               <a:buNone/>
             </a:pPr>
             <a:r>
@@ -7097,7 +6873,7 @@
           <a:bodyPr wrap="square" lIns="0" tIns="0" rIns="0" bIns="0" rtlCol="0" anchor="ctr"/>
           <a:lstStyle/>
           <a:p>
-            <a:pPr indent="0" marL="0">
+            <a:pPr marL="0" indent="0">
               <a:buNone/>
             </a:pPr>
             <a:r>
@@ -7136,7 +6912,7 @@
           <a:bodyPr wrap="square" lIns="0" tIns="0" rIns="0" bIns="0" rtlCol="0" anchor="ctr"/>
           <a:lstStyle/>
           <a:p>
-            <a:pPr algn="r" indent="0" marL="0">
+            <a:pPr marL="0" indent="0" algn="r">
               <a:buNone/>
             </a:pPr>
             <a:r>
@@ -7170,6 +6946,7 @@
         <a:solidFill>
           <a:srgbClr val="FFFFFF"/>
         </a:solidFill>
+        <a:effectLst/>
       </p:bgPr>
     </p:bg>
     <p:spTree>
@@ -7207,11 +6984,11 @@
           <a:bodyPr wrap="square" lIns="0" tIns="0" rIns="0" bIns="0" rtlCol="0" anchor="ctr"/>
           <a:lstStyle/>
           <a:p>
-            <a:pPr algn="l" indent="0" marL="0">
-              <a:buNone/>
-            </a:pPr>
-            <a:r>
-              <a:rPr lang="en-US" sz="1200" b="1" spc="200" kern="0" dirty="0">
+            <a:pPr marL="0" indent="0" algn="l">
+              <a:buNone/>
+            </a:pPr>
+            <a:r>
+              <a:rPr lang="en-US" sz="1200" b="1" kern="0" spc="200" dirty="0">
                 <a:solidFill>
                   <a:srgbClr val="0A8F7C"/>
                 </a:solidFill>
@@ -7246,7 +7023,7 @@
           <a:bodyPr wrap="square" lIns="0" tIns="0" rIns="0" bIns="0" rtlCol="0" anchor="ctr"/>
           <a:lstStyle/>
           <a:p>
-            <a:pPr algn="l" indent="0" marL="0">
+            <a:pPr marL="0" indent="0" algn="l">
               <a:buNone/>
             </a:pPr>
             <a:r>
@@ -7285,7 +7062,7 @@
           <a:bodyPr wrap="square" lIns="0" tIns="0" rIns="0" bIns="0" rtlCol="0" anchor="ctr"/>
           <a:lstStyle/>
           <a:p>
-            <a:pPr indent="0" marL="0">
+            <a:pPr marL="0" indent="0">
               <a:buNone/>
             </a:pPr>
             <a:r>
@@ -7324,7 +7101,7 @@
           </a:solidFill>
           <a:ln/>
           <a:effectLst>
-            <a:outerShdw sx="100000" sy="100000" kx="0" ky="0" algn="bl" rotWithShape="0" blurRad="101600" dist="38100" dir="5400000">
+            <a:outerShdw blurRad="101600" dist="38100" dir="5400000" algn="bl" rotWithShape="0">
               <a:srgbClr val="1C2542">
                 <a:alpha val="18000"/>
               </a:srgbClr>
@@ -7353,7 +7130,7 @@
           <a:bodyPr wrap="square" lIns="0" tIns="0" rIns="0" bIns="0" rtlCol="0" anchor="t"/>
           <a:lstStyle/>
           <a:p>
-            <a:pPr indent="0" marL="0">
+            <a:pPr marL="0" indent="0">
               <a:lnSpc>
                 <a:spcPct val="100000"/>
               </a:lnSpc>
@@ -7395,7 +7172,7 @@
           <a:bodyPr wrap="square" lIns="0" tIns="0" rIns="0" bIns="0" rtlCol="0" anchor="t"/>
           <a:lstStyle/>
           <a:p>
-            <a:pPr indent="0" marL="0">
+            <a:pPr marL="0" indent="0">
               <a:buNone/>
             </a:pPr>
             <a:r>
@@ -7412,7 +7189,7 @@
             <a:endParaRPr lang="en-US" sz="1250" dirty="0"/>
           </a:p>
           <a:p>
-            <a:pPr indent="0" marL="0">
+            <a:pPr marL="0" indent="0">
               <a:buNone/>
             </a:pPr>
             <a:r>
@@ -7451,7 +7228,7 @@
           </a:solidFill>
           <a:ln/>
           <a:effectLst>
-            <a:outerShdw sx="100000" sy="100000" kx="0" ky="0" algn="bl" rotWithShape="0" blurRad="101600" dist="38100" dir="5400000">
+            <a:outerShdw blurRad="101600" dist="38100" dir="5400000" algn="bl" rotWithShape="0">
               <a:srgbClr val="1C2542">
                 <a:alpha val="18000"/>
               </a:srgbClr>
@@ -7480,7 +7257,7 @@
           <a:bodyPr wrap="square" lIns="0" tIns="0" rIns="0" bIns="0" rtlCol="0" anchor="t"/>
           <a:lstStyle/>
           <a:p>
-            <a:pPr indent="0" marL="0">
+            <a:pPr marL="0" indent="0">
               <a:lnSpc>
                 <a:spcPct val="100000"/>
               </a:lnSpc>
@@ -7522,7 +7299,7 @@
           <a:bodyPr wrap="square" lIns="0" tIns="0" rIns="0" bIns="0" rtlCol="0" anchor="t"/>
           <a:lstStyle/>
           <a:p>
-            <a:pPr indent="0" marL="0">
+            <a:pPr marL="0" indent="0">
               <a:buNone/>
             </a:pPr>
             <a:r>
@@ -7539,7 +7316,7 @@
             <a:endParaRPr lang="en-US" sz="1250" dirty="0"/>
           </a:p>
           <a:p>
-            <a:pPr indent="0" marL="0">
+            <a:pPr marL="0" indent="0">
               <a:buNone/>
             </a:pPr>
             <a:r>
@@ -7578,7 +7355,7 @@
           </a:solidFill>
           <a:ln/>
           <a:effectLst>
-            <a:outerShdw sx="100000" sy="100000" kx="0" ky="0" algn="bl" rotWithShape="0" blurRad="101600" dist="38100" dir="5400000">
+            <a:outerShdw blurRad="101600" dist="38100" dir="5400000" algn="bl" rotWithShape="0">
               <a:srgbClr val="1C2542">
                 <a:alpha val="18000"/>
               </a:srgbClr>
@@ -7607,7 +7384,7 @@
           <a:bodyPr wrap="square" lIns="0" tIns="0" rIns="0" bIns="0" rtlCol="0" anchor="t"/>
           <a:lstStyle/>
           <a:p>
-            <a:pPr indent="0" marL="0">
+            <a:pPr marL="0" indent="0">
               <a:lnSpc>
                 <a:spcPct val="100000"/>
               </a:lnSpc>
@@ -7627,7 +7404,7 @@
             <a:endParaRPr lang="en-US" sz="2600" dirty="0"/>
           </a:p>
           <a:p>
-            <a:pPr indent="0" marL="0">
+            <a:pPr marL="0" indent="0">
               <a:lnSpc>
                 <a:spcPct val="100000"/>
               </a:lnSpc>
@@ -7669,7 +7446,7 @@
           <a:bodyPr wrap="square" lIns="0" tIns="0" rIns="0" bIns="0" rtlCol="0" anchor="t"/>
           <a:lstStyle/>
           <a:p>
-            <a:pPr indent="0" marL="0">
+            <a:pPr marL="0" indent="0">
               <a:buNone/>
             </a:pPr>
             <a:r>
@@ -7686,7 +7463,7 @@
             <a:endParaRPr lang="en-US" sz="1250" dirty="0"/>
           </a:p>
           <a:p>
-            <a:pPr indent="0" marL="0">
+            <a:pPr marL="0" indent="0">
               <a:buNone/>
             </a:pPr>
             <a:r>
@@ -7747,7 +7524,7 @@
           <a:bodyPr wrap="square" lIns="0" tIns="0" rIns="0" bIns="0" rtlCol="0" anchor="ctr"/>
           <a:lstStyle/>
           <a:p>
-            <a:pPr indent="0" marL="0">
+            <a:pPr marL="0" indent="0">
               <a:buNone/>
             </a:pPr>
             <a:r>
@@ -7786,7 +7563,7 @@
           <a:bodyPr wrap="square" lIns="0" tIns="0" rIns="0" bIns="0" rtlCol="0" anchor="t"/>
           <a:lstStyle/>
           <a:p>
-            <a:pPr indent="0" marL="0">
+            <a:pPr marL="0" indent="0">
               <a:buNone/>
             </a:pPr>
             <a:r>
@@ -7825,7 +7602,7 @@
           <a:bodyPr wrap="square" lIns="0" tIns="0" rIns="0" bIns="0" rtlCol="0" anchor="ctr"/>
           <a:lstStyle/>
           <a:p>
-            <a:pPr algn="r" indent="0" marL="0">
+            <a:pPr marL="0" indent="0" algn="r">
               <a:buNone/>
             </a:pPr>
             <a:r>
@@ -7859,6 +7636,7 @@
         <a:solidFill>
           <a:srgbClr val="0B0F1E"/>
         </a:solidFill>
+        <a:effectLst/>
       </p:bgPr>
     </p:bg>
     <p:spTree>
@@ -7896,11 +7674,11 @@
           <a:bodyPr wrap="square" lIns="0" tIns="0" rIns="0" bIns="0" rtlCol="0" anchor="ctr"/>
           <a:lstStyle/>
           <a:p>
-            <a:pPr algn="l" indent="0" marL="0">
-              <a:buNone/>
-            </a:pPr>
-            <a:r>
-              <a:rPr lang="en-US" sz="1200" b="1" spc="200" kern="0" dirty="0">
+            <a:pPr marL="0" indent="0" algn="l">
+              <a:buNone/>
+            </a:pPr>
+            <a:r>
+              <a:rPr lang="en-US" sz="1200" b="1" kern="0" spc="200" dirty="0">
                 <a:solidFill>
                   <a:srgbClr val="00D1B2"/>
                 </a:solidFill>
@@ -7935,7 +7713,7 @@
           <a:bodyPr wrap="square" lIns="0" tIns="0" rIns="0" bIns="0" rtlCol="0" anchor="ctr"/>
           <a:lstStyle/>
           <a:p>
-            <a:pPr algn="l" indent="0" marL="0">
+            <a:pPr marL="0" indent="0" algn="l">
               <a:buNone/>
             </a:pPr>
             <a:r>
@@ -7974,7 +7752,7 @@
           <a:bodyPr wrap="square" lIns="0" tIns="0" rIns="0" bIns="0" rtlCol="0" anchor="ctr"/>
           <a:lstStyle/>
           <a:p>
-            <a:pPr indent="0" marL="0">
+            <a:pPr marL="0" indent="0">
               <a:buNone/>
             </a:pPr>
             <a:r>
@@ -8040,11 +7818,11 @@
           <a:bodyPr wrap="square" lIns="0" tIns="0" rIns="0" bIns="0" rtlCol="0" anchor="ctr"/>
           <a:lstStyle/>
           <a:p>
-            <a:pPr indent="0" marL="0">
-              <a:buNone/>
-            </a:pPr>
-            <a:r>
-              <a:rPr lang="en-US" sz="1300" b="1" spc="150" kern="0" dirty="0">
+            <a:pPr marL="0" indent="0">
+              <a:buNone/>
+            </a:pPr>
+            <a:r>
+              <a:rPr lang="en-US" sz="1300" b="1" kern="0" spc="150" dirty="0">
                 <a:solidFill>
                   <a:srgbClr val="00D1B2"/>
                 </a:solidFill>
@@ -8266,11 +8044,11 @@
           <a:bodyPr wrap="square" lIns="0" tIns="0" rIns="0" bIns="0" rtlCol="0" anchor="ctr"/>
           <a:lstStyle/>
           <a:p>
-            <a:pPr indent="0" marL="0">
-              <a:buNone/>
-            </a:pPr>
-            <a:r>
-              <a:rPr lang="en-US" sz="1300" b="1" spc="150" kern="0" dirty="0">
+            <a:pPr marL="0" indent="0">
+              <a:buNone/>
+            </a:pPr>
+            <a:r>
+              <a:rPr lang="en-US" sz="1300" b="1" kern="0" spc="150" dirty="0">
                 <a:solidFill>
                   <a:srgbClr val="AAB4C8"/>
                 </a:solidFill>
@@ -8425,7 +8203,7 @@
           <a:bodyPr wrap="square" lIns="0" tIns="0" rIns="0" bIns="0" rtlCol="0" anchor="ctr"/>
           <a:lstStyle/>
           <a:p>
-            <a:pPr indent="0" marL="0">
+            <a:pPr marL="0" indent="0">
               <a:buNone/>
             </a:pPr>
             <a:r>
@@ -8464,7 +8242,7 @@
           <a:bodyPr wrap="square" lIns="0" tIns="0" rIns="0" bIns="0" rtlCol="0" anchor="ctr"/>
           <a:lstStyle/>
           <a:p>
-            <a:pPr algn="r" indent="0" marL="0">
+            <a:pPr marL="0" indent="0" algn="r">
               <a:buNone/>
             </a:pPr>
             <a:r>
@@ -8498,6 +8276,7 @@
         <a:solidFill>
           <a:srgbClr val="FFFFFF"/>
         </a:solidFill>
+        <a:effectLst/>
       </p:bgPr>
     </p:bg>
     <p:spTree>
@@ -8535,11 +8314,11 @@
           <a:bodyPr wrap="square" lIns="0" tIns="0" rIns="0" bIns="0" rtlCol="0" anchor="ctr"/>
           <a:lstStyle/>
           <a:p>
-            <a:pPr algn="l" indent="0" marL="0">
-              <a:buNone/>
-            </a:pPr>
-            <a:r>
-              <a:rPr lang="en-US" sz="1200" b="1" spc="200" kern="0" dirty="0">
+            <a:pPr marL="0" indent="0" algn="l">
+              <a:buNone/>
+            </a:pPr>
+            <a:r>
+              <a:rPr lang="en-US" sz="1200" b="1" kern="0" spc="200" dirty="0">
                 <a:solidFill>
                   <a:srgbClr val="0A8F7C"/>
                 </a:solidFill>
@@ -8574,7 +8353,7 @@
           <a:bodyPr wrap="square" lIns="0" tIns="0" rIns="0" bIns="0" rtlCol="0" anchor="ctr"/>
           <a:lstStyle/>
           <a:p>
-            <a:pPr algn="l" indent="0" marL="0">
+            <a:pPr marL="0" indent="0" algn="l">
               <a:buNone/>
             </a:pPr>
             <a:r>
@@ -8594,14 +8373,14 @@
       </p:sp>
       <p:pic>
         <p:nvPicPr>
-          <p:cNvPr id="4" name="Image 0" descr="/sessions/serene-friendly-newton/mnt/outputs/cyber-resilience-ai/assets/architecture_diagram.png">    </p:cNvPr>
+          <p:cNvPr id="4" name="Image 0" descr="/sessions/serene-friendly-newton/mnt/outputs/cyber-resilience-ai/assets/architecture_diagram.png"/>
           <p:cNvPicPr>
             <a:picLocks noChangeAspect="1"/>
           </p:cNvPicPr>
           <p:nvPr/>
         </p:nvPicPr>
         <p:blipFill>
-          <a:blip r:embed="rId1"/>
+          <a:blip r:embed="rId3"/>
           <a:stretch>
             <a:fillRect/>
           </a:stretch>
@@ -8637,7 +8416,7 @@
           <a:bodyPr wrap="square" lIns="0" tIns="0" rIns="0" bIns="0" rtlCol="0" anchor="ctr"/>
           <a:lstStyle/>
           <a:p>
-            <a:pPr indent="0" marL="0">
+            <a:pPr marL="0" indent="0">
               <a:buNone/>
             </a:pPr>
             <a:r>
@@ -8676,7 +8455,7 @@
           <a:bodyPr wrap="square" lIns="0" tIns="0" rIns="0" bIns="0" rtlCol="0" anchor="ctr"/>
           <a:lstStyle/>
           <a:p>
-            <a:pPr algn="r" indent="0" marL="0">
+            <a:pPr marL="0" indent="0" algn="r">
               <a:buNone/>
             </a:pPr>
             <a:r>
@@ -8710,6 +8489,7 @@
         <a:solidFill>
           <a:srgbClr val="0B0F1E"/>
         </a:solidFill>
+        <a:effectLst/>
       </p:bgPr>
     </p:bg>
     <p:spTree>
@@ -8747,11 +8527,11 @@
           <a:bodyPr wrap="square" lIns="0" tIns="0" rIns="0" bIns="0" rtlCol="0" anchor="ctr"/>
           <a:lstStyle/>
           <a:p>
-            <a:pPr algn="l" indent="0" marL="0">
-              <a:buNone/>
-            </a:pPr>
-            <a:r>
-              <a:rPr lang="en-US" sz="1200" b="1" spc="200" kern="0" dirty="0">
+            <a:pPr marL="0" indent="0" algn="l">
+              <a:buNone/>
+            </a:pPr>
+            <a:r>
+              <a:rPr lang="en-US" sz="1200" b="1" kern="0" spc="200" dirty="0">
                 <a:solidFill>
                   <a:srgbClr val="00D1B2"/>
                 </a:solidFill>
@@ -8786,7 +8566,7 @@
           <a:bodyPr wrap="square" lIns="0" tIns="0" rIns="0" bIns="0" rtlCol="0" anchor="ctr"/>
           <a:lstStyle/>
           <a:p>
-            <a:pPr algn="l" indent="0" marL="0">
+            <a:pPr marL="0" indent="0" algn="l">
               <a:buNone/>
             </a:pPr>
             <a:r>
@@ -8825,7 +8605,7 @@
           <a:bodyPr wrap="square" lIns="0" tIns="0" rIns="0" bIns="0" rtlCol="0" anchor="ctr"/>
           <a:lstStyle/>
           <a:p>
-            <a:pPr indent="0" marL="0">
+            <a:pPr marL="0" indent="0">
               <a:buNone/>
             </a:pPr>
             <a:r>
@@ -8889,7 +8669,7 @@
           <a:bodyPr wrap="square" lIns="0" tIns="0" rIns="0" bIns="0" rtlCol="0" anchor="ctr"/>
           <a:lstStyle/>
           <a:p>
-            <a:pPr algn="ctr" indent="0" marL="0">
+            <a:pPr marL="0" indent="0" algn="ctr">
               <a:buNone/>
             </a:pPr>
             <a:r>
@@ -8928,7 +8708,7 @@
           <a:bodyPr wrap="square" lIns="0" tIns="0" rIns="0" bIns="0" rtlCol="0" anchor="ctr"/>
           <a:lstStyle/>
           <a:p>
-            <a:pPr indent="0" marL="0">
+            <a:pPr marL="0" indent="0">
               <a:buNone/>
             </a:pPr>
             <a:r>
@@ -8967,7 +8747,7 @@
           <a:bodyPr wrap="square" lIns="0" tIns="0" rIns="0" bIns="0" rtlCol="0" anchor="ctr"/>
           <a:lstStyle/>
           <a:p>
-            <a:pPr indent="0" marL="0">
+            <a:pPr marL="0" indent="0">
               <a:buNone/>
             </a:pPr>
             <a:r>
@@ -9031,7 +8811,7 @@
           <a:bodyPr wrap="square" lIns="0" tIns="0" rIns="0" bIns="0" rtlCol="0" anchor="ctr"/>
           <a:lstStyle/>
           <a:p>
-            <a:pPr algn="ctr" indent="0" marL="0">
+            <a:pPr marL="0" indent="0" algn="ctr">
               <a:buNone/>
             </a:pPr>
             <a:r>
@@ -9070,7 +8850,7 @@
           <a:bodyPr wrap="square" lIns="0" tIns="0" rIns="0" bIns="0" rtlCol="0" anchor="ctr"/>
           <a:lstStyle/>
           <a:p>
-            <a:pPr indent="0" marL="0">
+            <a:pPr marL="0" indent="0">
               <a:buNone/>
             </a:pPr>
             <a:r>
@@ -9109,7 +8889,7 @@
           <a:bodyPr wrap="square" lIns="0" tIns="0" rIns="0" bIns="0" rtlCol="0" anchor="ctr"/>
           <a:lstStyle/>
           <a:p>
-            <a:pPr indent="0" marL="0">
+            <a:pPr marL="0" indent="0">
               <a:buNone/>
             </a:pPr>
             <a:r>
@@ -9173,7 +8953,7 @@
           <a:bodyPr wrap="square" lIns="0" tIns="0" rIns="0" bIns="0" rtlCol="0" anchor="ctr"/>
           <a:lstStyle/>
           <a:p>
-            <a:pPr algn="ctr" indent="0" marL="0">
+            <a:pPr marL="0" indent="0" algn="ctr">
               <a:buNone/>
             </a:pPr>
             <a:r>
@@ -9212,7 +8992,7 @@
           <a:bodyPr wrap="square" lIns="0" tIns="0" rIns="0" bIns="0" rtlCol="0" anchor="ctr"/>
           <a:lstStyle/>
           <a:p>
-            <a:pPr indent="0" marL="0">
+            <a:pPr marL="0" indent="0">
               <a:buNone/>
             </a:pPr>
             <a:r>
@@ -9251,7 +9031,7 @@
           <a:bodyPr wrap="square" lIns="0" tIns="0" rIns="0" bIns="0" rtlCol="0" anchor="ctr"/>
           <a:lstStyle/>
           <a:p>
-            <a:pPr indent="0" marL="0">
+            <a:pPr marL="0" indent="0">
               <a:buNone/>
             </a:pPr>
             <a:r>
@@ -9315,7 +9095,7 @@
           <a:bodyPr wrap="square" lIns="0" tIns="0" rIns="0" bIns="0" rtlCol="0" anchor="ctr"/>
           <a:lstStyle/>
           <a:p>
-            <a:pPr algn="ctr" indent="0" marL="0">
+            <a:pPr marL="0" indent="0" algn="ctr">
               <a:buNone/>
             </a:pPr>
             <a:r>
@@ -9354,7 +9134,7 @@
           <a:bodyPr wrap="square" lIns="0" tIns="0" rIns="0" bIns="0" rtlCol="0" anchor="ctr"/>
           <a:lstStyle/>
           <a:p>
-            <a:pPr indent="0" marL="0">
+            <a:pPr marL="0" indent="0">
               <a:buNone/>
             </a:pPr>
             <a:r>
@@ -9393,7 +9173,7 @@
           <a:bodyPr wrap="square" lIns="0" tIns="0" rIns="0" bIns="0" rtlCol="0" anchor="ctr"/>
           <a:lstStyle/>
           <a:p>
-            <a:pPr indent="0" marL="0">
+            <a:pPr marL="0" indent="0">
               <a:buNone/>
             </a:pPr>
             <a:r>
@@ -9432,7 +9212,7 @@
           <a:bodyPr wrap="square" lIns="0" tIns="0" rIns="0" bIns="0" rtlCol="0" anchor="ctr"/>
           <a:lstStyle/>
           <a:p>
-            <a:pPr algn="r" indent="0" marL="0">
+            <a:pPr marL="0" indent="0" algn="r">
               <a:buNone/>
             </a:pPr>
             <a:r>
@@ -9466,6 +9246,7 @@
         <a:solidFill>
           <a:srgbClr val="FFFFFF"/>
         </a:solidFill>
+        <a:effectLst/>
       </p:bgPr>
     </p:bg>
     <p:spTree>
@@ -9503,11 +9284,11 @@
           <a:bodyPr wrap="square" lIns="0" tIns="0" rIns="0" bIns="0" rtlCol="0" anchor="ctr"/>
           <a:lstStyle/>
           <a:p>
-            <a:pPr algn="l" indent="0" marL="0">
-              <a:buNone/>
-            </a:pPr>
-            <a:r>
-              <a:rPr lang="en-US" sz="1200" b="1" spc="200" kern="0" dirty="0">
+            <a:pPr marL="0" indent="0" algn="l">
+              <a:buNone/>
+            </a:pPr>
+            <a:r>
+              <a:rPr lang="en-US" sz="1200" b="1" kern="0" spc="200" dirty="0">
                 <a:solidFill>
                   <a:srgbClr val="0A8F7C"/>
                 </a:solidFill>
@@ -9542,7 +9323,7 @@
           <a:bodyPr wrap="square" lIns="0" tIns="0" rIns="0" bIns="0" rtlCol="0" anchor="ctr"/>
           <a:lstStyle/>
           <a:p>
-            <a:pPr algn="l" indent="0" marL="0">
+            <a:pPr marL="0" indent="0" algn="l">
               <a:buNone/>
             </a:pPr>
             <a:r>
@@ -9581,7 +9362,7 @@
           <a:bodyPr wrap="square" lIns="0" tIns="0" rIns="0" bIns="0" rtlCol="0" anchor="ctr"/>
           <a:lstStyle/>
           <a:p>
-            <a:pPr indent="0" marL="0">
+            <a:pPr marL="0" indent="0">
               <a:buNone/>
             </a:pPr>
             <a:r>
@@ -9620,7 +9401,7 @@
           </a:solidFill>
           <a:ln/>
           <a:effectLst>
-            <a:outerShdw sx="100000" sy="100000" kx="0" ky="0" algn="bl" rotWithShape="0" blurRad="76200" dist="25400" dir="5400000">
+            <a:outerShdw blurRad="76200" dist="25400" dir="5400000" algn="bl" rotWithShape="0">
               <a:srgbClr val="1C2542">
                 <a:alpha val="15000"/>
               </a:srgbClr>
@@ -9649,7 +9430,7 @@
           <a:bodyPr wrap="square" lIns="0" tIns="0" rIns="0" bIns="0" rtlCol="0" anchor="ctr"/>
           <a:lstStyle/>
           <a:p>
-            <a:pPr indent="0" marL="0">
+            <a:pPr marL="0" indent="0">
               <a:buNone/>
             </a:pPr>
             <a:r>
@@ -9688,7 +9469,7 @@
           <a:bodyPr wrap="square" lIns="0" tIns="0" rIns="0" bIns="0" rtlCol="0" anchor="ctr"/>
           <a:lstStyle/>
           <a:p>
-            <a:pPr indent="0" marL="0">
+            <a:pPr marL="0" indent="0">
               <a:buNone/>
             </a:pPr>
             <a:r>
@@ -9727,7 +9508,7 @@
           <a:bodyPr wrap="square" lIns="0" tIns="0" rIns="0" bIns="0" rtlCol="0" anchor="t"/>
           <a:lstStyle/>
           <a:p>
-            <a:pPr indent="0" marL="0">
+            <a:pPr marL="0" indent="0">
               <a:buNone/>
             </a:pPr>
             <a:r>
@@ -9766,7 +9547,7 @@
           <a:bodyPr wrap="square" lIns="0" tIns="0" rIns="0" bIns="0" rtlCol="0" anchor="ctr"/>
           <a:lstStyle/>
           <a:p>
-            <a:pPr algn="ctr" indent="0" marL="0">
+            <a:pPr marL="0" indent="0" algn="ctr">
               <a:buNone/>
             </a:pPr>
             <a:r>
@@ -9805,7 +9586,7 @@
           </a:solidFill>
           <a:ln/>
           <a:effectLst>
-            <a:outerShdw sx="100000" sy="100000" kx="0" ky="0" algn="bl" rotWithShape="0" blurRad="76200" dist="25400" dir="5400000">
+            <a:outerShdw blurRad="76200" dist="25400" dir="5400000" algn="bl" rotWithShape="0">
               <a:srgbClr val="1C2542">
                 <a:alpha val="15000"/>
               </a:srgbClr>
@@ -9834,7 +9615,7 @@
           <a:bodyPr wrap="square" lIns="0" tIns="0" rIns="0" bIns="0" rtlCol="0" anchor="ctr"/>
           <a:lstStyle/>
           <a:p>
-            <a:pPr indent="0" marL="0">
+            <a:pPr marL="0" indent="0">
               <a:buNone/>
             </a:pPr>
             <a:r>
@@ -9873,7 +9654,7 @@
           <a:bodyPr wrap="square" lIns="0" tIns="0" rIns="0" bIns="0" rtlCol="0" anchor="ctr"/>
           <a:lstStyle/>
           <a:p>
-            <a:pPr indent="0" marL="0">
+            <a:pPr marL="0" indent="0">
               <a:buNone/>
             </a:pPr>
             <a:r>
@@ -9912,7 +9693,7 @@
           <a:bodyPr wrap="square" lIns="0" tIns="0" rIns="0" bIns="0" rtlCol="0" anchor="t"/>
           <a:lstStyle/>
           <a:p>
-            <a:pPr indent="0" marL="0">
+            <a:pPr marL="0" indent="0">
               <a:buNone/>
             </a:pPr>
             <a:r>
@@ -9951,7 +9732,7 @@
           <a:bodyPr wrap="square" lIns="0" tIns="0" rIns="0" bIns="0" rtlCol="0" anchor="ctr"/>
           <a:lstStyle/>
           <a:p>
-            <a:pPr algn="ctr" indent="0" marL="0">
+            <a:pPr marL="0" indent="0" algn="ctr">
               <a:buNone/>
             </a:pPr>
             <a:r>
@@ -9990,7 +9771,7 @@
           </a:solidFill>
           <a:ln/>
           <a:effectLst>
-            <a:outerShdw sx="100000" sy="100000" kx="0" ky="0" algn="bl" rotWithShape="0" blurRad="76200" dist="25400" dir="5400000">
+            <a:outerShdw blurRad="76200" dist="25400" dir="5400000" algn="bl" rotWithShape="0">
               <a:srgbClr val="1C2542">
                 <a:alpha val="15000"/>
               </a:srgbClr>
@@ -10019,7 +9800,7 @@
           <a:bodyPr wrap="square" lIns="0" tIns="0" rIns="0" bIns="0" rtlCol="0" anchor="ctr"/>
           <a:lstStyle/>
           <a:p>
-            <a:pPr indent="0" marL="0">
+            <a:pPr marL="0" indent="0">
               <a:buNone/>
             </a:pPr>
             <a:r>
@@ -10058,7 +9839,7 @@
           <a:bodyPr wrap="square" lIns="0" tIns="0" rIns="0" bIns="0" rtlCol="0" anchor="ctr"/>
           <a:lstStyle/>
           <a:p>
-            <a:pPr indent="0" marL="0">
+            <a:pPr marL="0" indent="0">
               <a:buNone/>
             </a:pPr>
             <a:r>
@@ -10097,7 +9878,7 @@
           <a:bodyPr wrap="square" lIns="0" tIns="0" rIns="0" bIns="0" rtlCol="0" anchor="t"/>
           <a:lstStyle/>
           <a:p>
-            <a:pPr indent="0" marL="0">
+            <a:pPr marL="0" indent="0">
               <a:buNone/>
             </a:pPr>
             <a:r>
@@ -10136,7 +9917,7 @@
           <a:bodyPr wrap="square" lIns="0" tIns="0" rIns="0" bIns="0" rtlCol="0" anchor="ctr"/>
           <a:lstStyle/>
           <a:p>
-            <a:pPr algn="ctr" indent="0" marL="0">
+            <a:pPr marL="0" indent="0" algn="ctr">
               <a:buNone/>
             </a:pPr>
             <a:r>
@@ -10175,7 +9956,7 @@
           </a:solidFill>
           <a:ln/>
           <a:effectLst>
-            <a:outerShdw sx="100000" sy="100000" kx="0" ky="0" algn="bl" rotWithShape="0" blurRad="76200" dist="25400" dir="5400000">
+            <a:outerShdw blurRad="76200" dist="25400" dir="5400000" algn="bl" rotWithShape="0">
               <a:srgbClr val="1C2542">
                 <a:alpha val="15000"/>
               </a:srgbClr>
@@ -10204,7 +9985,7 @@
           <a:bodyPr wrap="square" lIns="0" tIns="0" rIns="0" bIns="0" rtlCol="0" anchor="ctr"/>
           <a:lstStyle/>
           <a:p>
-            <a:pPr indent="0" marL="0">
+            <a:pPr marL="0" indent="0">
               <a:buNone/>
             </a:pPr>
             <a:r>
@@ -10243,7 +10024,7 @@
           <a:bodyPr wrap="square" lIns="0" tIns="0" rIns="0" bIns="0" rtlCol="0" anchor="ctr"/>
           <a:lstStyle/>
           <a:p>
-            <a:pPr indent="0" marL="0">
+            <a:pPr marL="0" indent="0">
               <a:buNone/>
             </a:pPr>
             <a:r>
@@ -10282,7 +10063,7 @@
           <a:bodyPr wrap="square" lIns="0" tIns="0" rIns="0" bIns="0" rtlCol="0" anchor="t"/>
           <a:lstStyle/>
           <a:p>
-            <a:pPr indent="0" marL="0">
+            <a:pPr marL="0" indent="0">
               <a:buNone/>
             </a:pPr>
             <a:r>
@@ -10321,7 +10102,7 @@
           <a:bodyPr wrap="square" lIns="0" tIns="0" rIns="0" bIns="0" rtlCol="0" anchor="ctr"/>
           <a:lstStyle/>
           <a:p>
-            <a:pPr algn="r" indent="0" marL="0">
+            <a:pPr marL="0" indent="0" algn="r">
               <a:buNone/>
             </a:pPr>
             <a:r>
@@ -10355,6 +10136,7 @@
         <a:solidFill>
           <a:srgbClr val="0B0F1E"/>
         </a:solidFill>
+        <a:effectLst/>
       </p:bgPr>
     </p:bg>
     <p:spTree>
@@ -10392,11 +10174,11 @@
           <a:bodyPr wrap="square" lIns="0" tIns="0" rIns="0" bIns="0" rtlCol="0" anchor="ctr"/>
           <a:lstStyle/>
           <a:p>
-            <a:pPr algn="l" indent="0" marL="0">
-              <a:buNone/>
-            </a:pPr>
-            <a:r>
-              <a:rPr lang="en-US" sz="1200" b="1" spc="200" kern="0" dirty="0">
+            <a:pPr marL="0" indent="0" algn="l">
+              <a:buNone/>
+            </a:pPr>
+            <a:r>
+              <a:rPr lang="en-US" sz="1200" b="1" kern="0" spc="200" dirty="0">
                 <a:solidFill>
                   <a:srgbClr val="00D1B2"/>
                 </a:solidFill>
@@ -10431,7 +10213,7 @@
           <a:bodyPr wrap="square" lIns="0" tIns="0" rIns="0" bIns="0" rtlCol="0" anchor="ctr"/>
           <a:lstStyle/>
           <a:p>
-            <a:pPr algn="l" indent="0" marL="0">
+            <a:pPr marL="0" indent="0" algn="l">
               <a:buNone/>
             </a:pPr>
             <a:r>
@@ -10497,7 +10279,7 @@
           <a:bodyPr wrap="square" lIns="0" tIns="0" rIns="0" bIns="0" rtlCol="0" anchor="ctr"/>
           <a:lstStyle/>
           <a:p>
-            <a:pPr algn="ctr" indent="0" marL="0">
+            <a:pPr marL="0" indent="0" algn="ctr">
               <a:buNone/>
             </a:pPr>
             <a:r>
@@ -10536,7 +10318,7 @@
           <a:bodyPr wrap="square" lIns="0" tIns="0" rIns="0" bIns="0" rtlCol="0" anchor="ctr"/>
           <a:lstStyle/>
           <a:p>
-            <a:pPr algn="ctr" indent="0" marL="0">
+            <a:pPr marL="0" indent="0" algn="ctr">
               <a:buNone/>
             </a:pPr>
             <a:r>
@@ -10602,7 +10384,7 @@
           <a:bodyPr wrap="square" lIns="0" tIns="0" rIns="0" bIns="0" rtlCol="0" anchor="ctr"/>
           <a:lstStyle/>
           <a:p>
-            <a:pPr algn="ctr" indent="0" marL="0">
+            <a:pPr marL="0" indent="0" algn="ctr">
               <a:buNone/>
             </a:pPr>
             <a:r>
@@ -10641,7 +10423,7 @@
           <a:bodyPr wrap="square" lIns="0" tIns="0" rIns="0" bIns="0" rtlCol="0" anchor="ctr"/>
           <a:lstStyle/>
           <a:p>
-            <a:pPr algn="ctr" indent="0" marL="0">
+            <a:pPr marL="0" indent="0" algn="ctr">
               <a:buNone/>
             </a:pPr>
             <a:r>
@@ -10707,7 +10489,7 @@
           <a:bodyPr wrap="square" lIns="0" tIns="0" rIns="0" bIns="0" rtlCol="0" anchor="ctr"/>
           <a:lstStyle/>
           <a:p>
-            <a:pPr algn="ctr" indent="0" marL="0">
+            <a:pPr marL="0" indent="0" algn="ctr">
               <a:buNone/>
             </a:pPr>
             <a:r>
@@ -10746,7 +10528,7 @@
           <a:bodyPr wrap="square" lIns="0" tIns="0" rIns="0" bIns="0" rtlCol="0" anchor="ctr"/>
           <a:lstStyle/>
           <a:p>
-            <a:pPr algn="ctr" indent="0" marL="0">
+            <a:pPr marL="0" indent="0" algn="ctr">
               <a:buNone/>
             </a:pPr>
             <a:r>
@@ -10812,7 +10594,7 @@
           <a:bodyPr wrap="square" lIns="0" tIns="0" rIns="0" bIns="0" rtlCol="0" anchor="ctr"/>
           <a:lstStyle/>
           <a:p>
-            <a:pPr algn="ctr" indent="0" marL="0">
+            <a:pPr marL="0" indent="0" algn="ctr">
               <a:buNone/>
             </a:pPr>
             <a:r>
@@ -10851,7 +10633,7 @@
           <a:bodyPr wrap="square" lIns="0" tIns="0" rIns="0" bIns="0" rtlCol="0" anchor="ctr"/>
           <a:lstStyle/>
           <a:p>
-            <a:pPr algn="ctr" indent="0" marL="0">
+            <a:pPr marL="0" indent="0" algn="ctr">
               <a:buNone/>
             </a:pPr>
             <a:r>
@@ -10871,14 +10653,14 @@
       </p:sp>
       <p:pic>
         <p:nvPicPr>
-          <p:cNvPr id="16" name="Image 0" descr="/sessions/serene-friendly-newton/mnt/outputs/cyber-resilience-ai/eval/roc_curve.png">    </p:cNvPr>
+          <p:cNvPr id="16" name="Image 0" descr="/sessions/serene-friendly-newton/mnt/outputs/cyber-resilience-ai/eval/roc_curve.png"/>
           <p:cNvPicPr>
             <a:picLocks noChangeAspect="1"/>
           </p:cNvPicPr>
           <p:nvPr/>
         </p:nvPicPr>
         <p:blipFill>
-          <a:blip r:embed="rId1"/>
+          <a:blip r:embed="rId3"/>
           <a:stretch>
             <a:fillRect/>
           </a:stretch>
@@ -10895,14 +10677,14 @@
       </p:pic>
       <p:pic>
         <p:nvPicPr>
-          <p:cNvPr id="17" name="Image 1" descr="/sessions/serene-friendly-newton/mnt/outputs/cyber-resilience-ai/eval/pr_curve.png">    </p:cNvPr>
+          <p:cNvPr id="17" name="Image 1" descr="/sessions/serene-friendly-newton/mnt/outputs/cyber-resilience-ai/eval/pr_curve.png"/>
           <p:cNvPicPr>
             <a:picLocks noChangeAspect="1"/>
           </p:cNvPicPr>
           <p:nvPr/>
         </p:nvPicPr>
         <p:blipFill>
-          <a:blip r:embed="rId2"/>
+          <a:blip r:embed="rId4"/>
           <a:stretch>
             <a:fillRect/>
           </a:stretch>
@@ -10960,7 +10742,7 @@
           <a:bodyPr wrap="square" lIns="0" tIns="0" rIns="0" bIns="0" rtlCol="0" anchor="ctr"/>
           <a:lstStyle/>
           <a:p>
-            <a:pPr indent="0" marL="0">
+            <a:pPr marL="0" indent="0">
               <a:buNone/>
             </a:pPr>
             <a:r>
@@ -10999,7 +10781,7 @@
           <a:bodyPr wrap="square" lIns="0" tIns="0" rIns="0" bIns="0" rtlCol="0" anchor="t"/>
           <a:lstStyle/>
           <a:p>
-            <a:pPr indent="0" marL="0">
+            <a:pPr marL="0" indent="0">
               <a:buNone/>
             </a:pPr>
             <a:r>
@@ -11038,7 +10820,7 @@
           <a:bodyPr wrap="square" lIns="0" tIns="0" rIns="0" bIns="0" rtlCol="0" anchor="ctr"/>
           <a:lstStyle/>
           <a:p>
-            <a:pPr algn="r" indent="0" marL="0">
+            <a:pPr marL="0" indent="0" algn="r">
               <a:buNone/>
             </a:pPr>
             <a:r>
@@ -11072,6 +10854,7 @@
         <a:solidFill>
           <a:srgbClr val="FFFFFF"/>
         </a:solidFill>
+        <a:effectLst/>
       </p:bgPr>
     </p:bg>
     <p:spTree>
@@ -11109,11 +10892,11 @@
           <a:bodyPr wrap="square" lIns="0" tIns="0" rIns="0" bIns="0" rtlCol="0" anchor="ctr"/>
           <a:lstStyle/>
           <a:p>
-            <a:pPr algn="l" indent="0" marL="0">
-              <a:buNone/>
-            </a:pPr>
-            <a:r>
-              <a:rPr lang="en-US" sz="1200" b="1" spc="200" kern="0" dirty="0">
+            <a:pPr marL="0" indent="0" algn="l">
+              <a:buNone/>
+            </a:pPr>
+            <a:r>
+              <a:rPr lang="en-US" sz="1200" b="1" kern="0" spc="200" dirty="0">
                 <a:solidFill>
                   <a:srgbClr val="0A8F7C"/>
                 </a:solidFill>
@@ -11148,7 +10931,7 @@
           <a:bodyPr wrap="square" lIns="0" tIns="0" rIns="0" bIns="0" rtlCol="0" anchor="ctr"/>
           <a:lstStyle/>
           <a:p>
-            <a:pPr algn="l" indent="0" marL="0">
+            <a:pPr marL="0" indent="0" algn="l">
               <a:buNone/>
             </a:pPr>
             <a:r>
@@ -11168,7 +10951,7 @@
       </p:sp>
       <p:graphicFrame>
         <p:nvGraphicFramePr>
-          <p:cNvPr id="4" name="Chart 0" descr=""/>
+          <p:cNvPr id="4" name="Chart 0"/>
           <p:cNvGraphicFramePr/>
           <p:nvPr/>
         </p:nvGraphicFramePr>
@@ -11176,9 +10959,9 @@
           <a:off x="548640" y="1600200"/>
           <a:ext cx="7315200" cy="4206240"/>
         </p:xfrm>
-        <a:graphic xmlns:a="http://schemas.openxmlformats.org/drawingml/2006/main">
+        <a:graphic>
           <a:graphicData uri="http://schemas.openxmlformats.org/drawingml/2006/chart">
-            <c:chart xmlns:c="http://schemas.openxmlformats.org/drawingml/2006/chart" r:id="rId1"/>
+            <c:chart xmlns:c="http://schemas.openxmlformats.org/drawingml/2006/chart" xmlns:r="http://schemas.openxmlformats.org/officeDocument/2006/relationships" r:id="rId3"/>
           </a:graphicData>
         </a:graphic>
       </p:graphicFrame>
@@ -11225,7 +11008,7 @@
           <a:bodyPr wrap="square" lIns="0" tIns="0" rIns="0" bIns="0" rtlCol="0" anchor="ctr"/>
           <a:lstStyle/>
           <a:p>
-            <a:pPr indent="0" marL="0">
+            <a:pPr marL="0" indent="0">
               <a:buNone/>
             </a:pPr>
             <a:r>
@@ -11264,7 +11047,7 @@
           <a:bodyPr wrap="square" lIns="0" tIns="0" rIns="0" bIns="0" rtlCol="0" anchor="t"/>
           <a:lstStyle/>
           <a:p>
-            <a:pPr indent="0" marL="0">
+            <a:pPr marL="0" indent="0">
               <a:buNone/>
             </a:pPr>
             <a:r>
@@ -11281,13 +11064,13 @@
             <a:endParaRPr lang="en-US" sz="1200" dirty="0"/>
           </a:p>
           <a:p>
-            <a:pPr indent="0" marL="0">
+            <a:pPr marL="0" indent="0">
               <a:buNone/>
             </a:pPr>
             <a:endParaRPr lang="en-US" sz="1200" dirty="0"/>
           </a:p>
           <a:p>
-            <a:pPr indent="0" marL="0">
+            <a:pPr marL="0" indent="0">
               <a:buNone/>
             </a:pPr>
             <a:r>
@@ -11304,13 +11087,13 @@
             <a:endParaRPr lang="en-US" sz="1200" dirty="0"/>
           </a:p>
           <a:p>
-            <a:pPr indent="0" marL="0">
+            <a:pPr marL="0" indent="0">
               <a:buNone/>
             </a:pPr>
             <a:endParaRPr lang="en-US" sz="1200" dirty="0"/>
           </a:p>
           <a:p>
-            <a:pPr indent="0" marL="0">
+            <a:pPr marL="0" indent="0">
               <a:buNone/>
             </a:pPr>
             <a:r>
@@ -11349,7 +11132,7 @@
           <a:bodyPr wrap="square" lIns="0" tIns="0" rIns="0" bIns="0" rtlCol="0" anchor="ctr"/>
           <a:lstStyle/>
           <a:p>
-            <a:pPr algn="r" indent="0" marL="0">
+            <a:pPr marL="0" indent="0" algn="r">
               <a:buNone/>
             </a:pPr>
             <a:r>
@@ -11383,6 +11166,7 @@
         <a:solidFill>
           <a:srgbClr val="0B0F1E"/>
         </a:solidFill>
+        <a:effectLst/>
       </p:bgPr>
     </p:bg>
     <p:spTree>
@@ -11420,11 +11204,11 @@
           <a:bodyPr wrap="square" lIns="0" tIns="0" rIns="0" bIns="0" rtlCol="0" anchor="ctr"/>
           <a:lstStyle/>
           <a:p>
-            <a:pPr algn="l" indent="0" marL="0">
-              <a:buNone/>
-            </a:pPr>
-            <a:r>
-              <a:rPr lang="en-US" sz="1200" b="1" spc="200" kern="0" dirty="0">
+            <a:pPr marL="0" indent="0" algn="l">
+              <a:buNone/>
+            </a:pPr>
+            <a:r>
+              <a:rPr lang="en-US" sz="1200" b="1" kern="0" spc="200" dirty="0">
                 <a:solidFill>
                   <a:srgbClr val="00D1B2"/>
                 </a:solidFill>
@@ -11459,7 +11243,7 @@
           <a:bodyPr wrap="square" lIns="0" tIns="0" rIns="0" bIns="0" rtlCol="0" anchor="ctr"/>
           <a:lstStyle/>
           <a:p>
-            <a:pPr algn="l" indent="0" marL="0">
+            <a:pPr marL="0" indent="0" algn="l">
               <a:buNone/>
             </a:pPr>
             <a:r>
@@ -11498,7 +11282,7 @@
           <a:bodyPr wrap="square" lIns="0" tIns="0" rIns="0" bIns="0" rtlCol="0" anchor="ctr"/>
           <a:lstStyle/>
           <a:p>
-            <a:pPr indent="0" marL="0">
+            <a:pPr marL="0" indent="0">
               <a:buNone/>
             </a:pPr>
             <a:r>
@@ -11518,7 +11302,7 @@
       </p:sp>
       <p:graphicFrame>
         <p:nvGraphicFramePr>
-          <p:cNvPr id="5" name="Chart 0" descr=""/>
+          <p:cNvPr id="5" name="Chart 0"/>
           <p:cNvGraphicFramePr/>
           <p:nvPr/>
         </p:nvGraphicFramePr>
@@ -11526,9 +11310,9 @@
           <a:off x="548640" y="2148840"/>
           <a:ext cx="6309360" cy="3977640"/>
         </p:xfrm>
-        <a:graphic xmlns:a="http://schemas.openxmlformats.org/drawingml/2006/main">
+        <a:graphic>
           <a:graphicData uri="http://schemas.openxmlformats.org/drawingml/2006/chart">
-            <c:chart xmlns:c="http://schemas.openxmlformats.org/drawingml/2006/chart" r:id="rId1"/>
+            <c:chart xmlns:c="http://schemas.openxmlformats.org/drawingml/2006/chart" xmlns:r="http://schemas.openxmlformats.org/officeDocument/2006/relationships" r:id="rId3"/>
           </a:graphicData>
         </a:graphic>
       </p:graphicFrame>
@@ -11575,7 +11359,7 @@
           <a:bodyPr wrap="square" lIns="0" tIns="0" rIns="0" bIns="0" rtlCol="0" anchor="ctr"/>
           <a:lstStyle/>
           <a:p>
-            <a:pPr indent="0" marL="0">
+            <a:pPr marL="0" indent="0">
               <a:buNone/>
             </a:pPr>
             <a:r>
@@ -11614,7 +11398,7 @@
           <a:bodyPr wrap="square" lIns="0" tIns="0" rIns="0" bIns="0" rtlCol="0" anchor="t"/>
           <a:lstStyle/>
           <a:p>
-            <a:pPr indent="0" marL="0">
+            <a:pPr marL="0" indent="0">
               <a:buNone/>
             </a:pPr>
             <a:r>
@@ -11631,13 +11415,13 @@
             <a:endParaRPr lang="en-US" sz="1200" dirty="0"/>
           </a:p>
           <a:p>
-            <a:pPr indent="0" marL="0">
+            <a:pPr marL="0" indent="0">
               <a:buNone/>
             </a:pPr>
             <a:endParaRPr lang="en-US" sz="1200" dirty="0"/>
           </a:p>
           <a:p>
-            <a:pPr indent="0" marL="0">
+            <a:pPr marL="0" indent="0">
               <a:buNone/>
             </a:pPr>
             <a:r>
@@ -11654,13 +11438,13 @@
             <a:endParaRPr lang="en-US" sz="1200" dirty="0"/>
           </a:p>
           <a:p>
-            <a:pPr indent="0" marL="0">
+            <a:pPr marL="0" indent="0">
               <a:buNone/>
             </a:pPr>
             <a:endParaRPr lang="en-US" sz="1200" dirty="0"/>
           </a:p>
           <a:p>
-            <a:pPr indent="0" marL="0">
+            <a:pPr marL="0" indent="0">
               <a:buNone/>
             </a:pPr>
             <a:r>
@@ -11699,7 +11483,7 @@
           <a:bodyPr wrap="square" lIns="0" tIns="0" rIns="0" bIns="0" rtlCol="0" anchor="ctr"/>
           <a:lstStyle/>
           <a:p>
-            <a:pPr algn="r" indent="0" marL="0">
+            <a:pPr marL="0" indent="0" algn="r">
               <a:buNone/>
             </a:pPr>
             <a:r>
@@ -12018,4 +11802,319 @@
     </a:ext>
   </a:extLst>
 </a:theme>
+</file>
+
+<file path=ppt/theme/theme2.xml><?xml version="1.0" encoding="utf-8"?>
+<a:theme xmlns:a="http://schemas.openxmlformats.org/drawingml/2006/main" name="Office Theme">
+  <a:themeElements>
+    <a:clrScheme name="Office">
+      <a:dk1>
+        <a:sysClr val="windowText" lastClr="000000"/>
+      </a:dk1>
+      <a:lt1>
+        <a:sysClr val="window" lastClr="FFFFFF"/>
+      </a:lt1>
+      <a:dk2>
+        <a:srgbClr val="0E2841"/>
+      </a:dk2>
+      <a:lt2>
+        <a:srgbClr val="E8E8E8"/>
+      </a:lt2>
+      <a:accent1>
+        <a:srgbClr val="156082"/>
+      </a:accent1>
+      <a:accent2>
+        <a:srgbClr val="E97132"/>
+      </a:accent2>
+      <a:accent3>
+        <a:srgbClr val="196B24"/>
+      </a:accent3>
+      <a:accent4>
+        <a:srgbClr val="0F9ED5"/>
+      </a:accent4>
+      <a:accent5>
+        <a:srgbClr val="A02B93"/>
+      </a:accent5>
+      <a:accent6>
+        <a:srgbClr val="4EA72E"/>
+      </a:accent6>
+      <a:hlink>
+        <a:srgbClr val="467886"/>
+      </a:hlink>
+      <a:folHlink>
+        <a:srgbClr val="96607D"/>
+      </a:folHlink>
+    </a:clrScheme>
+    <a:fontScheme name="Office">
+      <a:majorFont>
+        <a:latin typeface="Aptos Display" panose="02110004020202020204"/>
+        <a:ea typeface=""/>
+        <a:cs typeface=""/>
+        <a:font script="Jpan" typeface="游ゴシック Light"/>
+        <a:font script="Hang" typeface="맑은 고딕"/>
+        <a:font script="Hans" typeface="等线 Light"/>
+        <a:font script="Hant" typeface="新細明體"/>
+        <a:font script="Arab" typeface="Times New Roman"/>
+        <a:font script="Hebr" typeface="Times New Roman"/>
+        <a:font script="Thai" typeface="Angsana New"/>
+        <a:font script="Ethi" typeface="Nyala"/>
+        <a:font script="Beng" typeface="Vrinda"/>
+        <a:font script="Gujr" typeface="Shruti"/>
+        <a:font script="Khmr" typeface="MoolBoran"/>
+        <a:font script="Knda" typeface="Tunga"/>
+        <a:font script="Guru" typeface="Raavi"/>
+        <a:font script="Cans" typeface="Euphemia"/>
+        <a:font script="Cher" typeface="Plantagenet Cherokee"/>
+        <a:font script="Yiii" typeface="Microsoft Yi Baiti"/>
+        <a:font script="Tibt" typeface="Microsoft Himalaya"/>
+        <a:font script="Thaa" typeface="MV Boli"/>
+        <a:font script="Deva" typeface="Mangal"/>
+        <a:font script="Telu" typeface="Gautami"/>
+        <a:font script="Taml" typeface="Latha"/>
+        <a:font script="Syrc" typeface="Estrangelo Edessa"/>
+        <a:font script="Orya" typeface="Kalinga"/>
+        <a:font script="Mlym" typeface="Kartika"/>
+        <a:font script="Laoo" typeface="DokChampa"/>
+        <a:font script="Sinh" typeface="Iskoola Pota"/>
+        <a:font script="Mong" typeface="Mongolian Baiti"/>
+        <a:font script="Viet" typeface="Times New Roman"/>
+        <a:font script="Uigh" typeface="Microsoft Uighur"/>
+        <a:font script="Geor" typeface="Sylfaen"/>
+        <a:font script="Armn" typeface="Arial"/>
+        <a:font script="Bugi" typeface="Leelawadee UI"/>
+        <a:font script="Bopo" typeface="Microsoft JhengHei"/>
+        <a:font script="Java" typeface="Javanese Text"/>
+        <a:font script="Lisu" typeface="Segoe UI"/>
+        <a:font script="Mymr" typeface="Myanmar Text"/>
+        <a:font script="Nkoo" typeface="Ebrima"/>
+        <a:font script="Olck" typeface="Nirmala UI"/>
+        <a:font script="Osma" typeface="Ebrima"/>
+        <a:font script="Phag" typeface="Phagspa"/>
+        <a:font script="Syrn" typeface="Estrangelo Edessa"/>
+        <a:font script="Syrj" typeface="Estrangelo Edessa"/>
+        <a:font script="Syre" typeface="Estrangelo Edessa"/>
+        <a:font script="Sora" typeface="Nirmala UI"/>
+        <a:font script="Tale" typeface="Microsoft Tai Le"/>
+        <a:font script="Talu" typeface="Microsoft New Tai Lue"/>
+        <a:font script="Tfng" typeface="Ebrima"/>
+      </a:majorFont>
+      <a:minorFont>
+        <a:latin typeface="Aptos" panose="02110004020202020204"/>
+        <a:ea typeface=""/>
+        <a:cs typeface=""/>
+        <a:font script="Jpan" typeface="游ゴシック"/>
+        <a:font script="Hang" typeface="맑은 고딕"/>
+        <a:font script="Hans" typeface="等线"/>
+        <a:font script="Hant" typeface="新細明體"/>
+        <a:font script="Arab" typeface="Arial"/>
+        <a:font script="Hebr" typeface="Arial"/>
+        <a:font script="Thai" typeface="Cordia New"/>
+        <a:font script="Ethi" typeface="Nyala"/>
+        <a:font script="Beng" typeface="Vrinda"/>
+        <a:font script="Gujr" typeface="Shruti"/>
+        <a:font script="Khmr" typeface="DaunPenh"/>
+        <a:font script="Knda" typeface="Tunga"/>
+        <a:font script="Guru" typeface="Raavi"/>
+        <a:font script="Cans" typeface="Euphemia"/>
+        <a:font script="Cher" typeface="Plantagenet Cherokee"/>
+        <a:font script="Yiii" typeface="Microsoft Yi Baiti"/>
+        <a:font script="Tibt" typeface="Microsoft Himalaya"/>
+        <a:font script="Thaa" typeface="MV Boli"/>
+        <a:font script="Deva" typeface="Mangal"/>
+        <a:font script="Telu" typeface="Gautami"/>
+        <a:font script="Taml" typeface="Latha"/>
+        <a:font script="Syrc" typeface="Estrangelo Edessa"/>
+        <a:font script="Orya" typeface="Kalinga"/>
+        <a:font script="Mlym" typeface="Kartika"/>
+        <a:font script="Laoo" typeface="DokChampa"/>
+        <a:font script="Sinh" typeface="Iskoola Pota"/>
+        <a:font script="Mong" typeface="Mongolian Baiti"/>
+        <a:font script="Viet" typeface="Arial"/>
+        <a:font script="Uigh" typeface="Microsoft Uighur"/>
+        <a:font script="Geor" typeface="Sylfaen"/>
+        <a:font script="Armn" typeface="Arial"/>
+        <a:font script="Bugi" typeface="Leelawadee UI"/>
+        <a:font script="Bopo" typeface="Microsoft JhengHei"/>
+        <a:font script="Java" typeface="Javanese Text"/>
+        <a:font script="Lisu" typeface="Segoe UI"/>
+        <a:font script="Mymr" typeface="Myanmar Text"/>
+        <a:font script="Nkoo" typeface="Ebrima"/>
+        <a:font script="Olck" typeface="Nirmala UI"/>
+        <a:font script="Osma" typeface="Ebrima"/>
+        <a:font script="Phag" typeface="Phagspa"/>
+        <a:font script="Syrn" typeface="Estrangelo Edessa"/>
+        <a:font script="Syrj" typeface="Estrangelo Edessa"/>
+        <a:font script="Syre" typeface="Estrangelo Edessa"/>
+        <a:font script="Sora" typeface="Nirmala UI"/>
+        <a:font script="Tale" typeface="Microsoft Tai Le"/>
+        <a:font script="Talu" typeface="Microsoft New Tai Lue"/>
+        <a:font script="Tfng" typeface="Ebrima"/>
+      </a:minorFont>
+    </a:fontScheme>
+    <a:fmtScheme name="Office">
+      <a:fillStyleLst>
+        <a:solidFill>
+          <a:schemeClr val="phClr"/>
+        </a:solidFill>
+        <a:gradFill rotWithShape="1">
+          <a:gsLst>
+            <a:gs pos="0">
+              <a:schemeClr val="phClr">
+                <a:lumMod val="110000"/>
+                <a:satMod val="105000"/>
+                <a:tint val="67000"/>
+              </a:schemeClr>
+            </a:gs>
+            <a:gs pos="50000">
+              <a:schemeClr val="phClr">
+                <a:lumMod val="105000"/>
+                <a:satMod val="103000"/>
+                <a:tint val="73000"/>
+              </a:schemeClr>
+            </a:gs>
+            <a:gs pos="100000">
+              <a:schemeClr val="phClr">
+                <a:lumMod val="105000"/>
+                <a:satMod val="109000"/>
+                <a:tint val="81000"/>
+              </a:schemeClr>
+            </a:gs>
+          </a:gsLst>
+          <a:lin ang="5400000" scaled="0"/>
+        </a:gradFill>
+        <a:gradFill rotWithShape="1">
+          <a:gsLst>
+            <a:gs pos="0">
+              <a:schemeClr val="phClr">
+                <a:satMod val="103000"/>
+                <a:lumMod val="102000"/>
+                <a:tint val="94000"/>
+              </a:schemeClr>
+            </a:gs>
+            <a:gs pos="50000">
+              <a:schemeClr val="phClr">
+                <a:satMod val="110000"/>
+                <a:lumMod val="100000"/>
+                <a:shade val="100000"/>
+              </a:schemeClr>
+            </a:gs>
+            <a:gs pos="100000">
+              <a:schemeClr val="phClr">
+                <a:lumMod val="99000"/>
+                <a:satMod val="120000"/>
+                <a:shade val="78000"/>
+              </a:schemeClr>
+            </a:gs>
+          </a:gsLst>
+          <a:lin ang="5400000" scaled="0"/>
+        </a:gradFill>
+      </a:fillStyleLst>
+      <a:lnStyleLst>
+        <a:ln w="12700" cap="flat" cmpd="sng" algn="ctr">
+          <a:solidFill>
+            <a:schemeClr val="phClr"/>
+          </a:solidFill>
+          <a:prstDash val="solid"/>
+          <a:miter lim="800000"/>
+        </a:ln>
+        <a:ln w="19050" cap="flat" cmpd="sng" algn="ctr">
+          <a:solidFill>
+            <a:schemeClr val="phClr"/>
+          </a:solidFill>
+          <a:prstDash val="solid"/>
+          <a:miter lim="800000"/>
+        </a:ln>
+        <a:ln w="25400" cap="flat" cmpd="sng" algn="ctr">
+          <a:solidFill>
+            <a:schemeClr val="phClr"/>
+          </a:solidFill>
+          <a:prstDash val="solid"/>
+          <a:miter lim="800000"/>
+        </a:ln>
+      </a:lnStyleLst>
+      <a:effectStyleLst>
+        <a:effectStyle>
+          <a:effectLst/>
+        </a:effectStyle>
+        <a:effectStyle>
+          <a:effectLst/>
+        </a:effectStyle>
+        <a:effectStyle>
+          <a:effectLst>
+            <a:outerShdw blurRad="57150" dist="19050" dir="5400000" algn="ctr" rotWithShape="0">
+              <a:srgbClr val="000000">
+                <a:alpha val="63000"/>
+              </a:srgbClr>
+            </a:outerShdw>
+          </a:effectLst>
+        </a:effectStyle>
+      </a:effectStyleLst>
+      <a:bgFillStyleLst>
+        <a:solidFill>
+          <a:schemeClr val="phClr"/>
+        </a:solidFill>
+        <a:solidFill>
+          <a:schemeClr val="phClr">
+            <a:tint val="95000"/>
+            <a:satMod val="170000"/>
+          </a:schemeClr>
+        </a:solidFill>
+        <a:gradFill rotWithShape="1">
+          <a:gsLst>
+            <a:gs pos="0">
+              <a:schemeClr val="phClr">
+                <a:tint val="93000"/>
+                <a:satMod val="150000"/>
+                <a:shade val="98000"/>
+                <a:lumMod val="102000"/>
+              </a:schemeClr>
+            </a:gs>
+            <a:gs pos="50000">
+              <a:schemeClr val="phClr">
+                <a:tint val="98000"/>
+                <a:satMod val="130000"/>
+                <a:shade val="90000"/>
+                <a:lumMod val="103000"/>
+              </a:schemeClr>
+            </a:gs>
+            <a:gs pos="100000">
+              <a:schemeClr val="phClr">
+                <a:shade val="63000"/>
+                <a:satMod val="120000"/>
+              </a:schemeClr>
+            </a:gs>
+          </a:gsLst>
+          <a:lin ang="5400000" scaled="0"/>
+        </a:gradFill>
+      </a:bgFillStyleLst>
+    </a:fmtScheme>
+  </a:themeElements>
+  <a:objectDefaults>
+    <a:lnDef>
+      <a:spPr/>
+      <a:bodyPr/>
+      <a:lstStyle/>
+      <a:style>
+        <a:lnRef idx="2">
+          <a:schemeClr val="accent1"/>
+        </a:lnRef>
+        <a:fillRef idx="0">
+          <a:schemeClr val="accent1"/>
+        </a:fillRef>
+        <a:effectRef idx="1">
+          <a:schemeClr val="accent1"/>
+        </a:effectRef>
+        <a:fontRef idx="minor">
+          <a:schemeClr val="tx1"/>
+        </a:fontRef>
+      </a:style>
+    </a:lnDef>
+  </a:objectDefaults>
+  <a:extraClrSchemeLst/>
+  <a:extLst>
+    <a:ext uri="{05A4C25C-085E-4340-85A3-A5531E510DB2}">
+      <thm15:themeFamily xmlns:thm15="http://schemas.microsoft.com/office/thememl/2012/main" name="Office Theme" id="{2E142A2C-CD16-42D6-873A-C26D2A0506FA}" vid="{1BDDFF52-6CD6-40A5-AB3C-68EB2F1E4D0A}"/>
+    </a:ext>
+  </a:extLst>
+</a:theme>
 </file>
</xml_diff>